<commit_message>
Re-audit v1.9 physical simulation and delivery
</commit_message>
<xml_diff>
--- a/delivery/Neyer_Gap_Test_v1_9_Presentation.pptx
+++ b/delivery/Neyer_Gap_Test_v1_9_Presentation.pptx
@@ -2,24 +2,24 @@
 <file path=ppt/presentation.xml><?xml version="1.0" encoding="utf-8"?>
 <p:presentation xmlns:p="http://schemas.openxmlformats.org/presentationml/2006/main">
   <p:sldMasterIdLst>
-    <p:sldMasterId xmlns:r="http://schemas.openxmlformats.org/officeDocument/2006/relationships" id="2147483648" r:id="R06bcb1ac1e044931"/>
+    <p:sldMasterId xmlns:r="http://schemas.openxmlformats.org/officeDocument/2006/relationships" id="2147483648" r:id="R29d268bc72a44e5a"/>
   </p:sldMasterIdLst>
   <p:notesMasterIdLst>
-    <p:notesMasterId xmlns:r="http://schemas.openxmlformats.org/officeDocument/2006/relationships" r:id="Rbb5d2e9b038a4885"/>
+    <p:notesMasterId xmlns:r="http://schemas.openxmlformats.org/officeDocument/2006/relationships" r:id="R42e501fb7476489d"/>
   </p:notesMasterIdLst>
   <p:sldIdLst>
-    <p:sldId xmlns:r="http://schemas.openxmlformats.org/officeDocument/2006/relationships" id="256" r:id="R77991596ad0a4803"/>
-    <p:sldId xmlns:r="http://schemas.openxmlformats.org/officeDocument/2006/relationships" id="257" r:id="R3088b6636535437e"/>
-    <p:sldId xmlns:r="http://schemas.openxmlformats.org/officeDocument/2006/relationships" id="258" r:id="R29a664fde50046c5"/>
-    <p:sldId xmlns:r="http://schemas.openxmlformats.org/officeDocument/2006/relationships" id="259" r:id="Rf6442ee6f3954372"/>
-    <p:sldId xmlns:r="http://schemas.openxmlformats.org/officeDocument/2006/relationships" id="260" r:id="R79d163e4905d4aae"/>
-    <p:sldId xmlns:r="http://schemas.openxmlformats.org/officeDocument/2006/relationships" id="261" r:id="Rf35e39bd820d41c8"/>
-    <p:sldId xmlns:r="http://schemas.openxmlformats.org/officeDocument/2006/relationships" id="262" r:id="Rab938fc675ba4fdd"/>
-    <p:sldId xmlns:r="http://schemas.openxmlformats.org/officeDocument/2006/relationships" id="263" r:id="R204894d5d3454202"/>
-    <p:sldId xmlns:r="http://schemas.openxmlformats.org/officeDocument/2006/relationships" id="264" r:id="Rf88cd2f576db42a8"/>
-    <p:sldId xmlns:r="http://schemas.openxmlformats.org/officeDocument/2006/relationships" id="265" r:id="R33bd4e2146bb4047"/>
-    <p:sldId xmlns:r="http://schemas.openxmlformats.org/officeDocument/2006/relationships" id="266" r:id="Rc6c59516675b487c"/>
-    <p:sldId xmlns:r="http://schemas.openxmlformats.org/officeDocument/2006/relationships" id="267" r:id="R7dc1356b09fe423a"/>
+    <p:sldId xmlns:r="http://schemas.openxmlformats.org/officeDocument/2006/relationships" id="256" r:id="R48bae8b675f244dc"/>
+    <p:sldId xmlns:r="http://schemas.openxmlformats.org/officeDocument/2006/relationships" id="257" r:id="R5fba481eead34301"/>
+    <p:sldId xmlns:r="http://schemas.openxmlformats.org/officeDocument/2006/relationships" id="258" r:id="R3de876aedcf74281"/>
+    <p:sldId xmlns:r="http://schemas.openxmlformats.org/officeDocument/2006/relationships" id="259" r:id="Rc907133fa73b4e9b"/>
+    <p:sldId xmlns:r="http://schemas.openxmlformats.org/officeDocument/2006/relationships" id="260" r:id="R703d525032f746a9"/>
+    <p:sldId xmlns:r="http://schemas.openxmlformats.org/officeDocument/2006/relationships" id="261" r:id="R6540d934b37844cd"/>
+    <p:sldId xmlns:r="http://schemas.openxmlformats.org/officeDocument/2006/relationships" id="262" r:id="R247e035d9a98424f"/>
+    <p:sldId xmlns:r="http://schemas.openxmlformats.org/officeDocument/2006/relationships" id="263" r:id="Rc0e0f702512b42bb"/>
+    <p:sldId xmlns:r="http://schemas.openxmlformats.org/officeDocument/2006/relationships" id="264" r:id="R790f9e2f764648dd"/>
+    <p:sldId xmlns:r="http://schemas.openxmlformats.org/officeDocument/2006/relationships" id="265" r:id="R28c46bacc460496d"/>
+    <p:sldId xmlns:r="http://schemas.openxmlformats.org/officeDocument/2006/relationships" id="266" r:id="Rc7c443ae85924335"/>
+    <p:sldId xmlns:r="http://schemas.openxmlformats.org/officeDocument/2006/relationships" id="267" r:id="Rada51f53d1d84261"/>
   </p:sldIdLst>
   <p:sldSz cx="12192000" cy="6858000"/>
   <p:notesSz cx="6858000" cy="9144000"/>
@@ -1243,7 +1243,7 @@
   </p:cSld>
   <p:clrMap bg1="lt1" tx1="dk1" bg2="lt2" tx2="dk2" accent1="accent1" accent2="accent2" accent3="accent3" accent4="accent4" accent5="accent5" accent6="accent6" hlink="hlink" folHlink="folHlink"/>
   <p:sldLayoutIdLst>
-    <p:sldLayoutId xmlns:r="http://schemas.openxmlformats.org/officeDocument/2006/relationships" id="2147483649" r:id="R66e43e66aff84dfc"/>
+    <p:sldLayoutId xmlns:r="http://schemas.openxmlformats.org/officeDocument/2006/relationships" id="2147483649" r:id="Re2703dbb4b684e32"/>
   </p:sldLayoutIdLst>
   <p:txStyles>
     <p:titleStyle>
@@ -2259,13 +2259,13 @@
               <c:formatCode>0.00%</c:formatCode>
               <c:ptCount val="3"/>
               <c:pt idx="0">
-                <c:v>0.9323</c:v>
+                <c:v>0.9402314814814815</c:v>
               </c:pt>
               <c:pt idx="1">
-                <c:v>0.9233</c:v>
+                <c:v>0.9336111111111114</c:v>
               </c:pt>
               <c:pt idx="2">
-                <c:v>0.9336</c:v>
+                <c:v>0.9353703703703705</c:v>
               </c:pt>
             </c:numLit>
           </c:val>
@@ -2300,13 +2300,13 @@
               <c:formatCode>0.00%</c:formatCode>
               <c:ptCount val="3"/>
               <c:pt idx="0">
-                <c:v>0.9728</c:v>
+                <c:v>0.9784259259259259</c:v>
               </c:pt>
               <c:pt idx="1">
-                <c:v>0.9792</c:v>
+                <c:v>0.9857407407407405</c:v>
               </c:pt>
               <c:pt idx="2">
-                <c:v>0.9964</c:v>
+                <c:v>0.9970370370370369</c:v>
               </c:pt>
             </c:numLit>
           </c:val>
@@ -2483,7 +2483,7 @@
           <p:cNvPr id="9" name="">
             <a:extLst xmlns:a="http://schemas.openxmlformats.org/drawingml/2006/main">
               <a:ext uri="{FF2B5EF4-FFF2-40B4-BE49-F238E27FC236}">
-                <a16:creationId xmlns:a16="http://schemas.microsoft.com/office/drawing/2014/main" id="{9A029366-4C16-402D-AE1B-7E96C7A53A84}"/>
+                <a16:creationId xmlns:a16="http://schemas.microsoft.com/office/drawing/2014/main" id="{E51D57D5-36E6-47A8-8706-24B800BD8576}"/>
               </a:ext>
             </a:extLst>
           </p:cNvPr>
@@ -2540,7 +2540,7 @@
           <p:cNvPr id="2" name="">
             <a:extLst xmlns:a="http://schemas.openxmlformats.org/drawingml/2006/main">
               <a:ext uri="{FF2B5EF4-FFF2-40B4-BE49-F238E27FC236}">
-                <a16:creationId xmlns:a16="http://schemas.microsoft.com/office/drawing/2014/main" id="{BDE496DA-F3CC-4B8F-BA8A-A3538B0B37CC}"/>
+                <a16:creationId xmlns:a16="http://schemas.microsoft.com/office/drawing/2014/main" id="{37786D56-7E2B-46E3-B759-B076BD0C66C1}"/>
               </a:ext>
             </a:extLst>
           </p:cNvPr>
@@ -2597,7 +2597,7 @@
           <p:cNvPr id="3" name="">
             <a:extLst xmlns:a="http://schemas.openxmlformats.org/drawingml/2006/main">
               <a:ext uri="{FF2B5EF4-FFF2-40B4-BE49-F238E27FC236}">
-                <a16:creationId xmlns:a16="http://schemas.microsoft.com/office/drawing/2014/main" id="{29E8721A-30AA-4424-97FD-255A96515885}"/>
+                <a16:creationId xmlns:a16="http://schemas.microsoft.com/office/drawing/2014/main" id="{3577C40A-B74A-4542-9A79-541D656A6BF4}"/>
               </a:ext>
             </a:extLst>
           </p:cNvPr>
@@ -2627,7 +2627,7 @@
           <p:cNvPr id="4" name="">
             <a:extLst xmlns:a="http://schemas.openxmlformats.org/drawingml/2006/main">
               <a:ext uri="{FF2B5EF4-FFF2-40B4-BE49-F238E27FC236}">
-                <a16:creationId xmlns:a16="http://schemas.microsoft.com/office/drawing/2014/main" id="{E9C8913E-C109-4984-A01E-B65A5FB355DE}"/>
+                <a16:creationId xmlns:a16="http://schemas.microsoft.com/office/drawing/2014/main" id="{3482B599-9700-4A5A-9951-574675C66AAF}"/>
               </a:ext>
             </a:extLst>
           </p:cNvPr>
@@ -2657,7 +2657,7 @@
           <p:cNvPr id="5" name="">
             <a:extLst xmlns:a="http://schemas.openxmlformats.org/drawingml/2006/main">
               <a:ext uri="{FF2B5EF4-FFF2-40B4-BE49-F238E27FC236}">
-                <a16:creationId xmlns:a16="http://schemas.microsoft.com/office/drawing/2014/main" id="{93ED9F3B-DD13-443C-BA24-E3F4B211D294}"/>
+                <a16:creationId xmlns:a16="http://schemas.microsoft.com/office/drawing/2014/main" id="{43932137-C6BA-40D1-AB45-E08A941DCC57}"/>
               </a:ext>
             </a:extLst>
           </p:cNvPr>
@@ -2687,7 +2687,7 @@
           <p:cNvPr id="6" name="">
             <a:extLst xmlns:a="http://schemas.openxmlformats.org/drawingml/2006/main">
               <a:ext uri="{FF2B5EF4-FFF2-40B4-BE49-F238E27FC236}">
-                <a16:creationId xmlns:a16="http://schemas.microsoft.com/office/drawing/2014/main" id="{9E7D7649-288F-410B-B956-7A9F1FBFA8A6}"/>
+                <a16:creationId xmlns:a16="http://schemas.microsoft.com/office/drawing/2014/main" id="{78C08BC5-4E84-4E8F-B7C6-1722B0914D0D}"/>
               </a:ext>
             </a:extLst>
           </p:cNvPr>
@@ -2744,7 +2744,7 @@
           <p:cNvPr id="7" name="">
             <a:extLst xmlns:a="http://schemas.openxmlformats.org/drawingml/2006/main">
               <a:ext uri="{FF2B5EF4-FFF2-40B4-BE49-F238E27FC236}">
-                <a16:creationId xmlns:a16="http://schemas.microsoft.com/office/drawing/2014/main" id="{B115ECB9-F626-4E55-B190-B6DFC6118C1A}"/>
+                <a16:creationId xmlns:a16="http://schemas.microsoft.com/office/drawing/2014/main" id="{9AD49418-6C72-4574-ACD7-682BF76FB017}"/>
               </a:ext>
             </a:extLst>
           </p:cNvPr>
@@ -2824,7 +2824,7 @@
           <p:cNvPr id="8" name="">
             <a:extLst xmlns:a="http://schemas.openxmlformats.org/drawingml/2006/main">
               <a:ext uri="{FF2B5EF4-FFF2-40B4-BE49-F238E27FC236}">
-                <a16:creationId xmlns:a16="http://schemas.microsoft.com/office/drawing/2014/main" id="{255817B9-C6E4-4F4C-AE12-72DDF47890FF}"/>
+                <a16:creationId xmlns:a16="http://schemas.microsoft.com/office/drawing/2014/main" id="{B3B44A24-D84D-498C-852C-972123D76944}"/>
               </a:ext>
             </a:extLst>
           </p:cNvPr>
@@ -2879,7 +2879,7 @@
     </p:spTree>
     <p:extLst>
       <p:ext uri="{BB962C8B-B14F-4D97-AF65-F5344CB8AC3E}">
-        <p14:creationId xmlns:p14="http://schemas.microsoft.com/office/powerpoint/2010/main" val="1893632015"/>
+        <p14:creationId xmlns:p14="http://schemas.microsoft.com/office/powerpoint/2010/main" val="158706680"/>
       </p:ext>
     </p:extLst>
   </p:cSld>
@@ -2910,7 +2910,7 @@
           <p:cNvPr id="6" name="">
             <a:extLst xmlns:a="http://schemas.openxmlformats.org/drawingml/2006/main">
               <a:ext uri="{FF2B5EF4-FFF2-40B4-BE49-F238E27FC236}">
-                <a16:creationId xmlns:a16="http://schemas.microsoft.com/office/drawing/2014/main" id="{6799517A-616D-4BF9-96C9-3AF6E9ABCA4F}"/>
+                <a16:creationId xmlns:a16="http://schemas.microsoft.com/office/drawing/2014/main" id="{CC2E5342-56D7-4D99-941D-61DD3AB57B59}"/>
               </a:ext>
             </a:extLst>
           </p:cNvPr>
@@ -2967,7 +2967,7 @@
           <p:cNvPr id="2" name="">
             <a:extLst xmlns:a="http://schemas.openxmlformats.org/drawingml/2006/main">
               <a:ext uri="{FF2B5EF4-FFF2-40B4-BE49-F238E27FC236}">
-                <a16:creationId xmlns:a16="http://schemas.microsoft.com/office/drawing/2014/main" id="{7F8717A9-674C-4FAF-8DAF-0502F2E78F19}"/>
+                <a16:creationId xmlns:a16="http://schemas.microsoft.com/office/drawing/2014/main" id="{27B95E04-376C-41FD-B035-86B11A5FE2ED}"/>
               </a:ext>
             </a:extLst>
           </p:cNvPr>
@@ -2997,7 +2997,7 @@
           <p:cNvPr id="3" name="">
             <a:extLst xmlns:a="http://schemas.openxmlformats.org/drawingml/2006/main">
               <a:ext uri="{FF2B5EF4-FFF2-40B4-BE49-F238E27FC236}">
-                <a16:creationId xmlns:a16="http://schemas.microsoft.com/office/drawing/2014/main" id="{F4F8E5F7-0705-46C6-8A46-5A46AF40DAE8}"/>
+                <a16:creationId xmlns:a16="http://schemas.microsoft.com/office/drawing/2014/main" id="{F1042373-C06E-4AE2-B649-0FDE72519A79}"/>
               </a:ext>
             </a:extLst>
           </p:cNvPr>
@@ -3428,7 +3428,7 @@
           <p:cNvPr id="5" name="">
             <a:extLst xmlns:a="http://schemas.openxmlformats.org/drawingml/2006/main">
               <a:ext uri="{FF2B5EF4-FFF2-40B4-BE49-F238E27FC236}">
-                <a16:creationId xmlns:a16="http://schemas.microsoft.com/office/drawing/2014/main" id="{34281460-AE6B-4269-BF12-186331449478}"/>
+                <a16:creationId xmlns:a16="http://schemas.microsoft.com/office/drawing/2014/main" id="{1B18407A-3BB6-479C-BF04-B230FC1DFA14}"/>
               </a:ext>
             </a:extLst>
           </p:cNvPr>
@@ -3483,7 +3483,7 @@
     </p:spTree>
     <p:extLst>
       <p:ext uri="{BB962C8B-B14F-4D97-AF65-F5344CB8AC3E}">
-        <p14:creationId xmlns:p14="http://schemas.microsoft.com/office/powerpoint/2010/main" val="1995015960"/>
+        <p14:creationId xmlns:p14="http://schemas.microsoft.com/office/powerpoint/2010/main" val="616640112"/>
       </p:ext>
     </p:extLst>
   </p:cSld>
@@ -3514,7 +3514,7 @@
           <p:cNvPr id="9" name="">
             <a:extLst xmlns:a="http://schemas.openxmlformats.org/drawingml/2006/main">
               <a:ext uri="{FF2B5EF4-FFF2-40B4-BE49-F238E27FC236}">
-                <a16:creationId xmlns:a16="http://schemas.microsoft.com/office/drawing/2014/main" id="{6CD3FCBD-AC5D-4BD6-AFCB-AF5F06DF2E1D}"/>
+                <a16:creationId xmlns:a16="http://schemas.microsoft.com/office/drawing/2014/main" id="{F2C8CBB7-278B-4F7B-88AA-D6C5C3EBABA8}"/>
               </a:ext>
             </a:extLst>
           </p:cNvPr>
@@ -3571,7 +3571,7 @@
           <p:cNvPr id="2" name="">
             <a:extLst xmlns:a="http://schemas.openxmlformats.org/drawingml/2006/main">
               <a:ext uri="{FF2B5EF4-FFF2-40B4-BE49-F238E27FC236}">
-                <a16:creationId xmlns:a16="http://schemas.microsoft.com/office/drawing/2014/main" id="{82288ACA-D5F4-45DD-87D6-B859D2A11590}"/>
+                <a16:creationId xmlns:a16="http://schemas.microsoft.com/office/drawing/2014/main" id="{91AFFB1D-78DA-4FD4-A060-2506C184CECF}"/>
               </a:ext>
             </a:extLst>
           </p:cNvPr>
@@ -3601,7 +3601,7 @@
           <p:cNvPr id="3" name="">
             <a:extLst xmlns:a="http://schemas.openxmlformats.org/drawingml/2006/main">
               <a:ext uri="{FF2B5EF4-FFF2-40B4-BE49-F238E27FC236}">
-                <a16:creationId xmlns:a16="http://schemas.microsoft.com/office/drawing/2014/main" id="{B27C5FC5-EF1D-4859-B0D4-10D9398A4D58}"/>
+                <a16:creationId xmlns:a16="http://schemas.microsoft.com/office/drawing/2014/main" id="{C9AFE90E-CD30-4006-A688-C57D7F6AF64B}"/>
               </a:ext>
             </a:extLst>
           </p:cNvPr>
@@ -3658,7 +3658,7 @@
           <p:cNvPr id="4" name="">
             <a:extLst xmlns:a="http://schemas.openxmlformats.org/drawingml/2006/main">
               <a:ext uri="{FF2B5EF4-FFF2-40B4-BE49-F238E27FC236}">
-                <a16:creationId xmlns:a16="http://schemas.microsoft.com/office/drawing/2014/main" id="{AE4535B8-390E-42EE-BF6D-2E2107DCB9E3}"/>
+                <a16:creationId xmlns:a16="http://schemas.microsoft.com/office/drawing/2014/main" id="{1EF82B49-508F-4584-90E9-3619CBD0BA1C}"/>
               </a:ext>
             </a:extLst>
           </p:cNvPr>
@@ -3948,7 +3948,7 @@
           <p:cNvPr id="6" name="">
             <a:extLst xmlns:a="http://schemas.openxmlformats.org/drawingml/2006/main">
               <a:ext uri="{FF2B5EF4-FFF2-40B4-BE49-F238E27FC236}">
-                <a16:creationId xmlns:a16="http://schemas.microsoft.com/office/drawing/2014/main" id="{81566A7D-EFBE-48EB-8F84-64009A023EAE}"/>
+                <a16:creationId xmlns:a16="http://schemas.microsoft.com/office/drawing/2014/main" id="{1B689F05-313C-4BEC-9917-4A952A5B8DF7}"/>
               </a:ext>
             </a:extLst>
           </p:cNvPr>
@@ -4005,7 +4005,7 @@
           <p:cNvPr id="7" name="">
             <a:extLst xmlns:a="http://schemas.openxmlformats.org/drawingml/2006/main">
               <a:ext uri="{FF2B5EF4-FFF2-40B4-BE49-F238E27FC236}">
-                <a16:creationId xmlns:a16="http://schemas.microsoft.com/office/drawing/2014/main" id="{CAB6D15E-3925-4249-975A-816B1F7644E8}"/>
+                <a16:creationId xmlns:a16="http://schemas.microsoft.com/office/drawing/2014/main" id="{69713847-43BA-40E0-949F-30326247E555}"/>
               </a:ext>
             </a:extLst>
           </p:cNvPr>
@@ -4062,7 +4062,7 @@
           <p:cNvPr id="8" name="">
             <a:extLst xmlns:a="http://schemas.openxmlformats.org/drawingml/2006/main">
               <a:ext uri="{FF2B5EF4-FFF2-40B4-BE49-F238E27FC236}">
-                <a16:creationId xmlns:a16="http://schemas.microsoft.com/office/drawing/2014/main" id="{D5DF50F8-9A04-483B-9891-4383A03F4B1A}"/>
+                <a16:creationId xmlns:a16="http://schemas.microsoft.com/office/drawing/2014/main" id="{5E899736-6E2D-4B6C-BCF9-6666235FAFDC}"/>
               </a:ext>
             </a:extLst>
           </p:cNvPr>
@@ -4117,7 +4117,7 @@
     </p:spTree>
     <p:extLst>
       <p:ext uri="{BB962C8B-B14F-4D97-AF65-F5344CB8AC3E}">
-        <p14:creationId xmlns:p14="http://schemas.microsoft.com/office/powerpoint/2010/main" val="1619215496"/>
+        <p14:creationId xmlns:p14="http://schemas.microsoft.com/office/powerpoint/2010/main" val="350994795"/>
       </p:ext>
     </p:extLst>
   </p:cSld>
@@ -4148,7 +4148,7 @@
           <p:cNvPr id="15" name="">
             <a:extLst xmlns:a="http://schemas.openxmlformats.org/drawingml/2006/main">
               <a:ext uri="{FF2B5EF4-FFF2-40B4-BE49-F238E27FC236}">
-                <a16:creationId xmlns:a16="http://schemas.microsoft.com/office/drawing/2014/main" id="{4207FF9F-D463-444C-BF44-8B32FBE5787B}"/>
+                <a16:creationId xmlns:a16="http://schemas.microsoft.com/office/drawing/2014/main" id="{ED432F1B-4841-410A-815E-8AEF367CF655}"/>
               </a:ext>
             </a:extLst>
           </p:cNvPr>
@@ -4205,7 +4205,7 @@
           <p:cNvPr id="2" name="">
             <a:extLst xmlns:a="http://schemas.openxmlformats.org/drawingml/2006/main">
               <a:ext uri="{FF2B5EF4-FFF2-40B4-BE49-F238E27FC236}">
-                <a16:creationId xmlns:a16="http://schemas.microsoft.com/office/drawing/2014/main" id="{D1BAA906-2823-4997-BE63-F28A22958D56}"/>
+                <a16:creationId xmlns:a16="http://schemas.microsoft.com/office/drawing/2014/main" id="{B24EA479-62E9-4D17-BF42-38B44B3F03E4}"/>
               </a:ext>
             </a:extLst>
           </p:cNvPr>
@@ -4235,7 +4235,7 @@
           <p:cNvPr id="3" name="">
             <a:extLst xmlns:a="http://schemas.openxmlformats.org/drawingml/2006/main">
               <a:ext uri="{FF2B5EF4-FFF2-40B4-BE49-F238E27FC236}">
-                <a16:creationId xmlns:a16="http://schemas.microsoft.com/office/drawing/2014/main" id="{B94CA5AE-AD0D-4BAE-A3C8-10D868C9542A}"/>
+                <a16:creationId xmlns:a16="http://schemas.microsoft.com/office/drawing/2014/main" id="{33D8078E-2AD1-4957-8FF6-91AC05EF14CB}"/>
               </a:ext>
             </a:extLst>
           </p:cNvPr>
@@ -4282,7 +4282,7 @@
                 <a:ea typeface="Aptos"/>
                 <a:cs typeface="Aptos"/>
               </a:rPr>
-              <a:t>77 / 77</a:t>
+              <a:t>95 / 95</a:t>
             </a:r>
           </a:p>
         </p:txBody>
@@ -4292,7 +4292,7 @@
           <p:cNvPr id="4" name="">
             <a:extLst xmlns:a="http://schemas.openxmlformats.org/drawingml/2006/main">
               <a:ext uri="{FF2B5EF4-FFF2-40B4-BE49-F238E27FC236}">
-                <a16:creationId xmlns:a16="http://schemas.microsoft.com/office/drawing/2014/main" id="{76F1EAD6-D7AE-4BBD-9A74-328AAA02A073}"/>
+                <a16:creationId xmlns:a16="http://schemas.microsoft.com/office/drawing/2014/main" id="{CFD5D869-6E76-49CF-A808-441FAD32B373}"/>
               </a:ext>
             </a:extLst>
           </p:cNvPr>
@@ -4349,7 +4349,7 @@
           <p:cNvPr id="5" name="">
             <a:extLst xmlns:a="http://schemas.openxmlformats.org/drawingml/2006/main">
               <a:ext uri="{FF2B5EF4-FFF2-40B4-BE49-F238E27FC236}">
-                <a16:creationId xmlns:a16="http://schemas.microsoft.com/office/drawing/2014/main" id="{B3F7F77F-7D25-472B-A0B7-A6C2D79947F4}"/>
+                <a16:creationId xmlns:a16="http://schemas.microsoft.com/office/drawing/2014/main" id="{F3419435-FF2F-49E7-A1C0-E5E2250A308B}"/>
               </a:ext>
             </a:extLst>
           </p:cNvPr>
@@ -4406,7 +4406,7 @@
           <p:cNvPr id="6" name="">
             <a:extLst xmlns:a="http://schemas.openxmlformats.org/drawingml/2006/main">
               <a:ext uri="{FF2B5EF4-FFF2-40B4-BE49-F238E27FC236}">
-                <a16:creationId xmlns:a16="http://schemas.microsoft.com/office/drawing/2014/main" id="{FB141D7C-42BE-4CA0-BA02-B658E82240D4}"/>
+                <a16:creationId xmlns:a16="http://schemas.microsoft.com/office/drawing/2014/main" id="{2D6573CF-D307-4B04-A518-58072E75DAFE}"/>
               </a:ext>
             </a:extLst>
           </p:cNvPr>
@@ -4463,7 +4463,7 @@
           <p:cNvPr id="7" name="">
             <a:extLst xmlns:a="http://schemas.openxmlformats.org/drawingml/2006/main">
               <a:ext uri="{FF2B5EF4-FFF2-40B4-BE49-F238E27FC236}">
-                <a16:creationId xmlns:a16="http://schemas.microsoft.com/office/drawing/2014/main" id="{FFB53D17-BEF6-4D9E-BB54-FA54808682E9}"/>
+                <a16:creationId xmlns:a16="http://schemas.microsoft.com/office/drawing/2014/main" id="{BE3DD806-D179-4BAC-A464-527B27D5FD13}"/>
               </a:ext>
             </a:extLst>
           </p:cNvPr>
@@ -4520,7 +4520,7 @@
           <p:cNvPr id="8" name="">
             <a:extLst xmlns:a="http://schemas.openxmlformats.org/drawingml/2006/main">
               <a:ext uri="{FF2B5EF4-FFF2-40B4-BE49-F238E27FC236}">
-                <a16:creationId xmlns:a16="http://schemas.microsoft.com/office/drawing/2014/main" id="{658ADD8C-09E1-4455-8735-7465885F8292}"/>
+                <a16:creationId xmlns:a16="http://schemas.microsoft.com/office/drawing/2014/main" id="{75F156CF-8D14-4C95-A655-7A756DB14BF4}"/>
               </a:ext>
             </a:extLst>
           </p:cNvPr>
@@ -4577,7 +4577,7 @@
           <p:cNvPr id="9" name="">
             <a:extLst xmlns:a="http://schemas.openxmlformats.org/drawingml/2006/main">
               <a:ext uri="{FF2B5EF4-FFF2-40B4-BE49-F238E27FC236}">
-                <a16:creationId xmlns:a16="http://schemas.microsoft.com/office/drawing/2014/main" id="{570FFA9D-739C-4F1D-A36C-99140B38E6C2}"/>
+                <a16:creationId xmlns:a16="http://schemas.microsoft.com/office/drawing/2014/main" id="{CAAE7368-2709-4FB9-A89A-7272DDA18AE0}"/>
               </a:ext>
             </a:extLst>
           </p:cNvPr>
@@ -4634,7 +4634,7 @@
           <p:cNvPr id="10" name="">
             <a:extLst xmlns:a="http://schemas.openxmlformats.org/drawingml/2006/main">
               <a:ext uri="{FF2B5EF4-FFF2-40B4-BE49-F238E27FC236}">
-                <a16:creationId xmlns:a16="http://schemas.microsoft.com/office/drawing/2014/main" id="{9A1C1360-2471-4ABB-9D17-417CB11352BD}"/>
+                <a16:creationId xmlns:a16="http://schemas.microsoft.com/office/drawing/2014/main" id="{49E800E1-44CE-444C-B393-CDBAD0D895D1}"/>
               </a:ext>
             </a:extLst>
           </p:cNvPr>
@@ -4691,7 +4691,7 @@
           <p:cNvPr id="11" name="">
             <a:extLst xmlns:a="http://schemas.openxmlformats.org/drawingml/2006/main">
               <a:ext uri="{FF2B5EF4-FFF2-40B4-BE49-F238E27FC236}">
-                <a16:creationId xmlns:a16="http://schemas.microsoft.com/office/drawing/2014/main" id="{4AB470D3-E097-4F7E-A1D9-2BC87A638CF6}"/>
+                <a16:creationId xmlns:a16="http://schemas.microsoft.com/office/drawing/2014/main" id="{A5027EBC-FE20-4A3D-8B85-1C98B057E163}"/>
               </a:ext>
             </a:extLst>
           </p:cNvPr>
@@ -4721,7 +4721,7 @@
           <p:cNvPr id="12" name="">
             <a:extLst xmlns:a="http://schemas.openxmlformats.org/drawingml/2006/main">
               <a:ext uri="{FF2B5EF4-FFF2-40B4-BE49-F238E27FC236}">
-                <a16:creationId xmlns:a16="http://schemas.microsoft.com/office/drawing/2014/main" id="{5A5A324F-2AE0-4CB6-A261-BFA1377C582A}"/>
+                <a16:creationId xmlns:a16="http://schemas.microsoft.com/office/drawing/2014/main" id="{EA791447-AC9D-48F9-A924-146DA93EF70E}"/>
               </a:ext>
             </a:extLst>
           </p:cNvPr>
@@ -4778,7 +4778,7 @@
           <p:cNvPr id="13" name="">
             <a:extLst xmlns:a="http://schemas.openxmlformats.org/drawingml/2006/main">
               <a:ext uri="{FF2B5EF4-FFF2-40B4-BE49-F238E27FC236}">
-                <a16:creationId xmlns:a16="http://schemas.microsoft.com/office/drawing/2014/main" id="{4A6C2DEE-2569-4221-ADF1-AEF88A64C847}"/>
+                <a16:creationId xmlns:a16="http://schemas.microsoft.com/office/drawing/2014/main" id="{E1AB7630-35F0-464A-9825-9FA2D6A20A00}"/>
               </a:ext>
             </a:extLst>
           </p:cNvPr>
@@ -4835,7 +4835,7 @@
           <p:cNvPr id="14" name="">
             <a:extLst xmlns:a="http://schemas.openxmlformats.org/drawingml/2006/main">
               <a:ext uri="{FF2B5EF4-FFF2-40B4-BE49-F238E27FC236}">
-                <a16:creationId xmlns:a16="http://schemas.microsoft.com/office/drawing/2014/main" id="{EDAE432C-8BAE-4757-88A2-CFB11179611D}"/>
+                <a16:creationId xmlns:a16="http://schemas.microsoft.com/office/drawing/2014/main" id="{2A24FF55-39D9-4DFC-B95D-16B293169DE5}"/>
               </a:ext>
             </a:extLst>
           </p:cNvPr>
@@ -4890,7 +4890,7 @@
     </p:spTree>
     <p:extLst>
       <p:ext uri="{BB962C8B-B14F-4D97-AF65-F5344CB8AC3E}">
-        <p14:creationId xmlns:p14="http://schemas.microsoft.com/office/powerpoint/2010/main" val="735931515"/>
+        <p14:creationId xmlns:p14="http://schemas.microsoft.com/office/powerpoint/2010/main" val="951181584"/>
       </p:ext>
     </p:extLst>
   </p:cSld>
@@ -4921,7 +4921,7 @@
           <p:cNvPr id="17" name="">
             <a:extLst xmlns:a="http://schemas.openxmlformats.org/drawingml/2006/main">
               <a:ext uri="{FF2B5EF4-FFF2-40B4-BE49-F238E27FC236}">
-                <a16:creationId xmlns:a16="http://schemas.microsoft.com/office/drawing/2014/main" id="{88E7F9FF-FB00-43E0-9BCE-CCDA62E2F124}"/>
+                <a16:creationId xmlns:a16="http://schemas.microsoft.com/office/drawing/2014/main" id="{9FA5D61D-84C8-4A3C-A46E-B031EC8B6503}"/>
               </a:ext>
             </a:extLst>
           </p:cNvPr>
@@ -4978,7 +4978,7 @@
           <p:cNvPr id="2" name="">
             <a:extLst xmlns:a="http://schemas.openxmlformats.org/drawingml/2006/main">
               <a:ext uri="{FF2B5EF4-FFF2-40B4-BE49-F238E27FC236}">
-                <a16:creationId xmlns:a16="http://schemas.microsoft.com/office/drawing/2014/main" id="{BFA70CF7-7E5C-4277-A443-CCF37318B96D}"/>
+                <a16:creationId xmlns:a16="http://schemas.microsoft.com/office/drawing/2014/main" id="{3F00CC91-7BE7-47A9-8B94-5992A2C131B0}"/>
               </a:ext>
             </a:extLst>
           </p:cNvPr>
@@ -5008,7 +5008,7 @@
           <p:cNvPr id="3" name="">
             <a:extLst xmlns:a="http://schemas.openxmlformats.org/drawingml/2006/main">
               <a:ext uri="{FF2B5EF4-FFF2-40B4-BE49-F238E27FC236}">
-                <a16:creationId xmlns:a16="http://schemas.microsoft.com/office/drawing/2014/main" id="{0EAAA817-D95C-41D5-BEE2-2CAEB599C091}"/>
+                <a16:creationId xmlns:a16="http://schemas.microsoft.com/office/drawing/2014/main" id="{0BADEFD6-3DB2-44BE-8CF0-3BD53B0E63DE}"/>
               </a:ext>
             </a:extLst>
           </p:cNvPr>
@@ -5069,7 +5069,7 @@
           <p:nvPr/>
         </p:nvPicPr>
         <p:blipFill>
-          <a:blip xmlns:r="http://schemas.openxmlformats.org/officeDocument/2006/relationships" xmlns:a="http://schemas.openxmlformats.org/drawingml/2006/main" r:embed="R887cf09a07a24d93"/>
+          <a:blip xmlns:r="http://schemas.openxmlformats.org/officeDocument/2006/relationships" xmlns:a="http://schemas.openxmlformats.org/drawingml/2006/main" r:embed="Rf43a7590ae8a4808"/>
           <a:stretch xmlns:a="http://schemas.openxmlformats.org/drawingml/2006/main"/>
         </p:blipFill>
         <p:spPr>
@@ -5087,7 +5087,7 @@
           <p:cNvPr id="5" name="">
             <a:extLst xmlns:a="http://schemas.openxmlformats.org/drawingml/2006/main">
               <a:ext uri="{FF2B5EF4-FFF2-40B4-BE49-F238E27FC236}">
-                <a16:creationId xmlns:a16="http://schemas.microsoft.com/office/drawing/2014/main" id="{95C0C5C2-FA06-4235-9A28-8A8AB4D039B0}"/>
+                <a16:creationId xmlns:a16="http://schemas.microsoft.com/office/drawing/2014/main" id="{FBCB84F5-6F5F-4125-BD75-FD093978369A}"/>
               </a:ext>
             </a:extLst>
           </p:cNvPr>
@@ -5144,7 +5144,7 @@
           <p:cNvPr id="6" name="">
             <a:extLst xmlns:a="http://schemas.openxmlformats.org/drawingml/2006/main">
               <a:ext uri="{FF2B5EF4-FFF2-40B4-BE49-F238E27FC236}">
-                <a16:creationId xmlns:a16="http://schemas.microsoft.com/office/drawing/2014/main" id="{89DF8161-DD96-4063-88F8-BB1533DB231B}"/>
+                <a16:creationId xmlns:a16="http://schemas.microsoft.com/office/drawing/2014/main" id="{6C28D8E0-6386-4B43-9230-79C340EF21DA}"/>
               </a:ext>
             </a:extLst>
           </p:cNvPr>
@@ -5201,7 +5201,7 @@
           <p:cNvPr id="7" name="">
             <a:extLst xmlns:a="http://schemas.openxmlformats.org/drawingml/2006/main">
               <a:ext uri="{FF2B5EF4-FFF2-40B4-BE49-F238E27FC236}">
-                <a16:creationId xmlns:a16="http://schemas.microsoft.com/office/drawing/2014/main" id="{87DBF095-025B-4BBE-8AE6-C65E0657B4E2}"/>
+                <a16:creationId xmlns:a16="http://schemas.microsoft.com/office/drawing/2014/main" id="{7E7402F1-71BF-4721-B0B7-FE00358E2F6F}"/>
               </a:ext>
             </a:extLst>
           </p:cNvPr>
@@ -5258,7 +5258,7 @@
           <p:cNvPr id="8" name="">
             <a:extLst xmlns:a="http://schemas.openxmlformats.org/drawingml/2006/main">
               <a:ext uri="{FF2B5EF4-FFF2-40B4-BE49-F238E27FC236}">
-                <a16:creationId xmlns:a16="http://schemas.microsoft.com/office/drawing/2014/main" id="{727FCB33-56C3-4F4B-925A-09DE3868F6AD}"/>
+                <a16:creationId xmlns:a16="http://schemas.microsoft.com/office/drawing/2014/main" id="{2AD33FAF-7EE9-4D42-9B6B-9D6A21240500}"/>
               </a:ext>
             </a:extLst>
           </p:cNvPr>
@@ -5315,7 +5315,7 @@
           <p:cNvPr id="9" name="">
             <a:extLst xmlns:a="http://schemas.openxmlformats.org/drawingml/2006/main">
               <a:ext uri="{FF2B5EF4-FFF2-40B4-BE49-F238E27FC236}">
-                <a16:creationId xmlns:a16="http://schemas.microsoft.com/office/drawing/2014/main" id="{0E4ECF05-DD09-4F06-86D7-86B4DB287185}"/>
+                <a16:creationId xmlns:a16="http://schemas.microsoft.com/office/drawing/2014/main" id="{8EC79523-A7EB-4529-9E3A-EA6408B718AB}"/>
               </a:ext>
             </a:extLst>
           </p:cNvPr>
@@ -5372,7 +5372,7 @@
           <p:cNvPr id="10" name="">
             <a:extLst xmlns:a="http://schemas.openxmlformats.org/drawingml/2006/main">
               <a:ext uri="{FF2B5EF4-FFF2-40B4-BE49-F238E27FC236}">
-                <a16:creationId xmlns:a16="http://schemas.microsoft.com/office/drawing/2014/main" id="{0ECAE857-BF28-4ADB-B1A2-BFAAA5592EA9}"/>
+                <a16:creationId xmlns:a16="http://schemas.microsoft.com/office/drawing/2014/main" id="{E7C01C5B-B037-4681-BFB3-6F4BE095C4FE}"/>
               </a:ext>
             </a:extLst>
           </p:cNvPr>
@@ -5429,7 +5429,7 @@
           <p:cNvPr id="11" name="">
             <a:extLst xmlns:a="http://schemas.openxmlformats.org/drawingml/2006/main">
               <a:ext uri="{FF2B5EF4-FFF2-40B4-BE49-F238E27FC236}">
-                <a16:creationId xmlns:a16="http://schemas.microsoft.com/office/drawing/2014/main" id="{5FF3181E-CCBB-4137-BAEF-AE63A1035823}"/>
+                <a16:creationId xmlns:a16="http://schemas.microsoft.com/office/drawing/2014/main" id="{A2FE8C65-609D-4FD9-9AE2-C0B01D562DD8}"/>
               </a:ext>
             </a:extLst>
           </p:cNvPr>
@@ -5486,7 +5486,7 @@
           <p:cNvPr id="12" name="">
             <a:extLst xmlns:a="http://schemas.openxmlformats.org/drawingml/2006/main">
               <a:ext uri="{FF2B5EF4-FFF2-40B4-BE49-F238E27FC236}">
-                <a16:creationId xmlns:a16="http://schemas.microsoft.com/office/drawing/2014/main" id="{3D7DA83F-E496-4A0F-9EC6-65985570CCA0}"/>
+                <a16:creationId xmlns:a16="http://schemas.microsoft.com/office/drawing/2014/main" id="{30764E0D-716E-4E7A-940E-2C720E300732}"/>
               </a:ext>
             </a:extLst>
           </p:cNvPr>
@@ -5543,7 +5543,7 @@
           <p:cNvPr id="13" name="">
             <a:extLst xmlns:a="http://schemas.openxmlformats.org/drawingml/2006/main">
               <a:ext uri="{FF2B5EF4-FFF2-40B4-BE49-F238E27FC236}">
-                <a16:creationId xmlns:a16="http://schemas.microsoft.com/office/drawing/2014/main" id="{549CF7F0-A4E2-4D84-96D8-261DB8FA8FE5}"/>
+                <a16:creationId xmlns:a16="http://schemas.microsoft.com/office/drawing/2014/main" id="{738BAF9E-2AF6-4B36-9E33-9F1AAB104353}"/>
               </a:ext>
             </a:extLst>
           </p:cNvPr>
@@ -5573,7 +5573,7 @@
           <p:cNvPr id="14" name="">
             <a:extLst xmlns:a="http://schemas.openxmlformats.org/drawingml/2006/main">
               <a:ext uri="{FF2B5EF4-FFF2-40B4-BE49-F238E27FC236}">
-                <a16:creationId xmlns:a16="http://schemas.microsoft.com/office/drawing/2014/main" id="{B45AF65C-E7A9-4082-9D9A-5127FC017C55}"/>
+                <a16:creationId xmlns:a16="http://schemas.microsoft.com/office/drawing/2014/main" id="{D6B0692C-1573-4598-A8E6-F1F3F80B220E}"/>
               </a:ext>
             </a:extLst>
           </p:cNvPr>
@@ -5603,7 +5603,7 @@
           <p:cNvPr id="15" name="">
             <a:extLst xmlns:a="http://schemas.openxmlformats.org/drawingml/2006/main">
               <a:ext uri="{FF2B5EF4-FFF2-40B4-BE49-F238E27FC236}">
-                <a16:creationId xmlns:a16="http://schemas.microsoft.com/office/drawing/2014/main" id="{646CDA6E-93AD-474C-8449-DEE497C3F6D9}"/>
+                <a16:creationId xmlns:a16="http://schemas.microsoft.com/office/drawing/2014/main" id="{F4894919-8F44-4AB5-A369-531C81AAA5A3}"/>
               </a:ext>
             </a:extLst>
           </p:cNvPr>
@@ -5633,7 +5633,7 @@
           <p:cNvPr id="16" name="">
             <a:extLst xmlns:a="http://schemas.openxmlformats.org/drawingml/2006/main">
               <a:ext uri="{FF2B5EF4-FFF2-40B4-BE49-F238E27FC236}">
-                <a16:creationId xmlns:a16="http://schemas.microsoft.com/office/drawing/2014/main" id="{6457203A-3EDD-41EE-A5A8-EFFC133E7B42}"/>
+                <a16:creationId xmlns:a16="http://schemas.microsoft.com/office/drawing/2014/main" id="{42755349-E32B-41CC-A8E3-9178EC139A2E}"/>
               </a:ext>
             </a:extLst>
           </p:cNvPr>
@@ -5688,7 +5688,7 @@
     </p:spTree>
     <p:extLst>
       <p:ext uri="{BB962C8B-B14F-4D97-AF65-F5344CB8AC3E}">
-        <p14:creationId xmlns:p14="http://schemas.microsoft.com/office/powerpoint/2010/main" val="472938368"/>
+        <p14:creationId xmlns:p14="http://schemas.microsoft.com/office/powerpoint/2010/main" val="1519160331"/>
       </p:ext>
     </p:extLst>
   </p:cSld>
@@ -5719,7 +5719,7 @@
           <p:cNvPr id="6" name="">
             <a:extLst xmlns:a="http://schemas.openxmlformats.org/drawingml/2006/main">
               <a:ext uri="{FF2B5EF4-FFF2-40B4-BE49-F238E27FC236}">
-                <a16:creationId xmlns:a16="http://schemas.microsoft.com/office/drawing/2014/main" id="{05A2DABF-EF8B-41C9-AE6F-39A39F4D3D40}"/>
+                <a16:creationId xmlns:a16="http://schemas.microsoft.com/office/drawing/2014/main" id="{74CB18F5-5B2A-4377-9679-33CC64D24482}"/>
               </a:ext>
             </a:extLst>
           </p:cNvPr>
@@ -5776,7 +5776,7 @@
           <p:cNvPr id="2" name="">
             <a:extLst xmlns:a="http://schemas.openxmlformats.org/drawingml/2006/main">
               <a:ext uri="{FF2B5EF4-FFF2-40B4-BE49-F238E27FC236}">
-                <a16:creationId xmlns:a16="http://schemas.microsoft.com/office/drawing/2014/main" id="{E13A267A-3130-4754-99D1-675FDDEB814B}"/>
+                <a16:creationId xmlns:a16="http://schemas.microsoft.com/office/drawing/2014/main" id="{50A679EA-E29F-49A8-8F1D-668F16BC7AF0}"/>
               </a:ext>
             </a:extLst>
           </p:cNvPr>
@@ -5806,7 +5806,7 @@
           <p:cNvPr id="3" name="">
             <a:extLst xmlns:a="http://schemas.openxmlformats.org/drawingml/2006/main">
               <a:ext uri="{FF2B5EF4-FFF2-40B4-BE49-F238E27FC236}">
-                <a16:creationId xmlns:a16="http://schemas.microsoft.com/office/drawing/2014/main" id="{141D3558-F231-41DD-B41D-66C1B2B4388F}"/>
+                <a16:creationId xmlns:a16="http://schemas.microsoft.com/office/drawing/2014/main" id="{AE681BFE-EE9A-4780-842D-CF8B77BD6EE5}"/>
               </a:ext>
             </a:extLst>
           </p:cNvPr>
@@ -6430,7 +6430,7 @@
           <p:cNvPr id="5" name="">
             <a:extLst xmlns:a="http://schemas.openxmlformats.org/drawingml/2006/main">
               <a:ext uri="{FF2B5EF4-FFF2-40B4-BE49-F238E27FC236}">
-                <a16:creationId xmlns:a16="http://schemas.microsoft.com/office/drawing/2014/main" id="{4C572186-39E4-4B79-B04C-68F8B762A71F}"/>
+                <a16:creationId xmlns:a16="http://schemas.microsoft.com/office/drawing/2014/main" id="{FCDC18A5-3806-4EBF-9DB0-6E624F24F043}"/>
               </a:ext>
             </a:extLst>
           </p:cNvPr>
@@ -6485,7 +6485,7 @@
     </p:spTree>
     <p:extLst>
       <p:ext uri="{BB962C8B-B14F-4D97-AF65-F5344CB8AC3E}">
-        <p14:creationId xmlns:p14="http://schemas.microsoft.com/office/powerpoint/2010/main" val="1655825947"/>
+        <p14:creationId xmlns:p14="http://schemas.microsoft.com/office/powerpoint/2010/main" val="1383853570"/>
       </p:ext>
     </p:extLst>
   </p:cSld>
@@ -6516,7 +6516,7 @@
           <p:cNvPr id="11" name="">
             <a:extLst xmlns:a="http://schemas.openxmlformats.org/drawingml/2006/main">
               <a:ext uri="{FF2B5EF4-FFF2-40B4-BE49-F238E27FC236}">
-                <a16:creationId xmlns:a16="http://schemas.microsoft.com/office/drawing/2014/main" id="{C84717FD-E70D-4861-90C2-9C869489007E}"/>
+                <a16:creationId xmlns:a16="http://schemas.microsoft.com/office/drawing/2014/main" id="{43F08359-8069-4B57-94B7-AB16E7B4DB80}"/>
               </a:ext>
             </a:extLst>
           </p:cNvPr>
@@ -6573,7 +6573,7 @@
           <p:cNvPr id="2" name="">
             <a:extLst xmlns:a="http://schemas.openxmlformats.org/drawingml/2006/main">
               <a:ext uri="{FF2B5EF4-FFF2-40B4-BE49-F238E27FC236}">
-                <a16:creationId xmlns:a16="http://schemas.microsoft.com/office/drawing/2014/main" id="{F8ADDC7B-1D7C-4DCF-91D7-2E481DEB528F}"/>
+                <a16:creationId xmlns:a16="http://schemas.microsoft.com/office/drawing/2014/main" id="{220D6A54-F4F9-4E69-8582-4420C4D4712B}"/>
               </a:ext>
             </a:extLst>
           </p:cNvPr>
@@ -6603,7 +6603,7 @@
           <p:cNvPr id="3" name="">
             <a:extLst xmlns:a="http://schemas.openxmlformats.org/drawingml/2006/main">
               <a:ext uri="{FF2B5EF4-FFF2-40B4-BE49-F238E27FC236}">
-                <a16:creationId xmlns:a16="http://schemas.microsoft.com/office/drawing/2014/main" id="{412C6855-8B60-40E7-972E-5FF7666FBF5E}"/>
+                <a16:creationId xmlns:a16="http://schemas.microsoft.com/office/drawing/2014/main" id="{69A560DD-1989-415E-A67B-B640C50C249C}"/>
               </a:ext>
             </a:extLst>
           </p:cNvPr>
@@ -6660,7 +6660,7 @@
           <p:cNvPr id="4" name="">
             <a:extLst xmlns:a="http://schemas.openxmlformats.org/drawingml/2006/main">
               <a:ext uri="{FF2B5EF4-FFF2-40B4-BE49-F238E27FC236}">
-                <a16:creationId xmlns:a16="http://schemas.microsoft.com/office/drawing/2014/main" id="{C9742041-A45F-4E65-9FA1-0D118E040158}"/>
+                <a16:creationId xmlns:a16="http://schemas.microsoft.com/office/drawing/2014/main" id="{E0E28B2D-976B-4FA6-9AB6-D9331742528B}"/>
               </a:ext>
             </a:extLst>
           </p:cNvPr>
@@ -6717,7 +6717,7 @@
           <p:cNvPr id="5" name="">
             <a:extLst xmlns:a="http://schemas.openxmlformats.org/drawingml/2006/main">
               <a:ext uri="{FF2B5EF4-FFF2-40B4-BE49-F238E27FC236}">
-                <a16:creationId xmlns:a16="http://schemas.microsoft.com/office/drawing/2014/main" id="{4982D837-9D57-477D-8BCA-0A8E390B07AA}"/>
+                <a16:creationId xmlns:a16="http://schemas.microsoft.com/office/drawing/2014/main" id="{4C18FD7D-5354-49C2-A4AD-9BDCC83F3854}"/>
               </a:ext>
             </a:extLst>
           </p:cNvPr>
@@ -6774,7 +6774,7 @@
           <p:cNvPr id="6" name="">
             <a:extLst xmlns:a="http://schemas.openxmlformats.org/drawingml/2006/main">
               <a:ext uri="{FF2B5EF4-FFF2-40B4-BE49-F238E27FC236}">
-                <a16:creationId xmlns:a16="http://schemas.microsoft.com/office/drawing/2014/main" id="{D33BEEFB-E608-4BA7-B60C-27FC76E570B3}"/>
+                <a16:creationId xmlns:a16="http://schemas.microsoft.com/office/drawing/2014/main" id="{B0C0339D-657B-48D6-83C4-5EE5BA48D8F4}"/>
               </a:ext>
             </a:extLst>
           </p:cNvPr>
@@ -6831,7 +6831,7 @@
           <p:cNvPr id="7" name="">
             <a:extLst xmlns:a="http://schemas.openxmlformats.org/drawingml/2006/main">
               <a:ext uri="{FF2B5EF4-FFF2-40B4-BE49-F238E27FC236}">
-                <a16:creationId xmlns:a16="http://schemas.microsoft.com/office/drawing/2014/main" id="{D461BF9E-BAB5-4737-8995-EF5E73B05061}"/>
+                <a16:creationId xmlns:a16="http://schemas.microsoft.com/office/drawing/2014/main" id="{2E1BFE14-10A5-4527-87B3-5D69EAFF79CF}"/>
               </a:ext>
             </a:extLst>
           </p:cNvPr>
@@ -7183,7 +7183,7 @@
           <p:cNvPr id="9" name="">
             <a:extLst xmlns:a="http://schemas.openxmlformats.org/drawingml/2006/main">
               <a:ext uri="{FF2B5EF4-FFF2-40B4-BE49-F238E27FC236}">
-                <a16:creationId xmlns:a16="http://schemas.microsoft.com/office/drawing/2014/main" id="{C6E5E8F3-0BE3-4C7C-B09D-EAD7DE9E731C}"/>
+                <a16:creationId xmlns:a16="http://schemas.microsoft.com/office/drawing/2014/main" id="{45AF8A72-F5C1-41D8-90B7-569B39416363}"/>
               </a:ext>
             </a:extLst>
           </p:cNvPr>
@@ -7240,7 +7240,7 @@
           <p:cNvPr id="10" name="">
             <a:extLst xmlns:a="http://schemas.openxmlformats.org/drawingml/2006/main">
               <a:ext uri="{FF2B5EF4-FFF2-40B4-BE49-F238E27FC236}">
-                <a16:creationId xmlns:a16="http://schemas.microsoft.com/office/drawing/2014/main" id="{3B066580-0711-405D-A508-D696C65D394E}"/>
+                <a16:creationId xmlns:a16="http://schemas.microsoft.com/office/drawing/2014/main" id="{5DE60EBC-85ED-4B8C-BCF9-4FF5C4972CA7}"/>
               </a:ext>
             </a:extLst>
           </p:cNvPr>
@@ -7295,7 +7295,7 @@
     </p:spTree>
     <p:extLst>
       <p:ext uri="{BB962C8B-B14F-4D97-AF65-F5344CB8AC3E}">
-        <p14:creationId xmlns:p14="http://schemas.microsoft.com/office/powerpoint/2010/main" val="392198611"/>
+        <p14:creationId xmlns:p14="http://schemas.microsoft.com/office/powerpoint/2010/main" val="1591916715"/>
       </p:ext>
     </p:extLst>
   </p:cSld>
@@ -7326,7 +7326,7 @@
           <p:cNvPr id="8" name="">
             <a:extLst xmlns:a="http://schemas.openxmlformats.org/drawingml/2006/main">
               <a:ext uri="{FF2B5EF4-FFF2-40B4-BE49-F238E27FC236}">
-                <a16:creationId xmlns:a16="http://schemas.microsoft.com/office/drawing/2014/main" id="{4B008387-653D-4F4F-9206-2800BFAB779D}"/>
+                <a16:creationId xmlns:a16="http://schemas.microsoft.com/office/drawing/2014/main" id="{3B8F31B2-924A-4704-95B1-922311F2D9D2}"/>
               </a:ext>
             </a:extLst>
           </p:cNvPr>
@@ -7383,7 +7383,7 @@
           <p:cNvPr id="2" name="">
             <a:extLst xmlns:a="http://schemas.openxmlformats.org/drawingml/2006/main">
               <a:ext uri="{FF2B5EF4-FFF2-40B4-BE49-F238E27FC236}">
-                <a16:creationId xmlns:a16="http://schemas.microsoft.com/office/drawing/2014/main" id="{3CC08131-DED3-4826-BA29-79B8C972E9AF}"/>
+                <a16:creationId xmlns:a16="http://schemas.microsoft.com/office/drawing/2014/main" id="{EC5F4C7A-2C40-4C87-A5F5-5C8E502318CC}"/>
               </a:ext>
             </a:extLst>
           </p:cNvPr>
@@ -7413,7 +7413,7 @@
           <p:cNvPr id="3" name="">
             <a:extLst xmlns:a="http://schemas.openxmlformats.org/drawingml/2006/main">
               <a:ext uri="{FF2B5EF4-FFF2-40B4-BE49-F238E27FC236}">
-                <a16:creationId xmlns:a16="http://schemas.microsoft.com/office/drawing/2014/main" id="{AF4D20B9-A26D-4291-AEE9-77A0EC8B03A0}"/>
+                <a16:creationId xmlns:a16="http://schemas.microsoft.com/office/drawing/2014/main" id="{28EE63A0-6294-49C0-8CDE-9424AFE9BE1E}"/>
               </a:ext>
             </a:extLst>
           </p:cNvPr>
@@ -7765,7 +7765,7 @@
           <p:cNvPr id="5" name="">
             <a:extLst xmlns:a="http://schemas.openxmlformats.org/drawingml/2006/main">
               <a:ext uri="{FF2B5EF4-FFF2-40B4-BE49-F238E27FC236}">
-                <a16:creationId xmlns:a16="http://schemas.microsoft.com/office/drawing/2014/main" id="{195FF4DE-2A8E-48A3-8564-C26EF732C40E}"/>
+                <a16:creationId xmlns:a16="http://schemas.microsoft.com/office/drawing/2014/main" id="{E4BAC0AB-EAE0-4459-B8BC-7817F79E3256}"/>
               </a:ext>
             </a:extLst>
           </p:cNvPr>
@@ -7822,7 +7822,7 @@
           <p:cNvPr id="6" name="">
             <a:extLst xmlns:a="http://schemas.openxmlformats.org/drawingml/2006/main">
               <a:ext uri="{FF2B5EF4-FFF2-40B4-BE49-F238E27FC236}">
-                <a16:creationId xmlns:a16="http://schemas.microsoft.com/office/drawing/2014/main" id="{7DB422F3-ED6C-4220-82BC-DA184B4C1219}"/>
+                <a16:creationId xmlns:a16="http://schemas.microsoft.com/office/drawing/2014/main" id="{E32C5807-6C87-4DB5-A211-EAEDC8FB4D60}"/>
               </a:ext>
             </a:extLst>
           </p:cNvPr>
@@ -7879,7 +7879,7 @@
           <p:cNvPr id="7" name="">
             <a:extLst xmlns:a="http://schemas.openxmlformats.org/drawingml/2006/main">
               <a:ext uri="{FF2B5EF4-FFF2-40B4-BE49-F238E27FC236}">
-                <a16:creationId xmlns:a16="http://schemas.microsoft.com/office/drawing/2014/main" id="{E711F2F6-B59C-4C50-95A8-325E24C05F77}"/>
+                <a16:creationId xmlns:a16="http://schemas.microsoft.com/office/drawing/2014/main" id="{179A8097-FC9B-4A91-9521-E6D5CF51F7F2}"/>
               </a:ext>
             </a:extLst>
           </p:cNvPr>
@@ -7934,7 +7934,7 @@
     </p:spTree>
     <p:extLst>
       <p:ext uri="{BB962C8B-B14F-4D97-AF65-F5344CB8AC3E}">
-        <p14:creationId xmlns:p14="http://schemas.microsoft.com/office/powerpoint/2010/main" val="1123465837"/>
+        <p14:creationId xmlns:p14="http://schemas.microsoft.com/office/powerpoint/2010/main" val="321471551"/>
       </p:ext>
     </p:extLst>
   </p:cSld>
@@ -7965,7 +7965,7 @@
           <p:cNvPr id="8" name="">
             <a:extLst xmlns:a="http://schemas.openxmlformats.org/drawingml/2006/main">
               <a:ext uri="{FF2B5EF4-FFF2-40B4-BE49-F238E27FC236}">
-                <a16:creationId xmlns:a16="http://schemas.microsoft.com/office/drawing/2014/main" id="{30AA3816-3FE1-4459-B3E8-161A689B14A5}"/>
+                <a16:creationId xmlns:a16="http://schemas.microsoft.com/office/drawing/2014/main" id="{1CD2DFF0-7C4E-45CC-A72F-B116364C4C3E}"/>
               </a:ext>
             </a:extLst>
           </p:cNvPr>
@@ -8022,7 +8022,7 @@
           <p:cNvPr id="2" name="">
             <a:extLst xmlns:a="http://schemas.openxmlformats.org/drawingml/2006/main">
               <a:ext uri="{FF2B5EF4-FFF2-40B4-BE49-F238E27FC236}">
-                <a16:creationId xmlns:a16="http://schemas.microsoft.com/office/drawing/2014/main" id="{ACEEB942-A278-41DF-9580-C8B428CCB865}"/>
+                <a16:creationId xmlns:a16="http://schemas.microsoft.com/office/drawing/2014/main" id="{D5DB96B1-EA94-42F4-8661-1621AE96108E}"/>
               </a:ext>
             </a:extLst>
           </p:cNvPr>
@@ -8052,7 +8052,7 @@
           <p:cNvPr id="3" name="">
             <a:extLst xmlns:a="http://schemas.openxmlformats.org/drawingml/2006/main">
               <a:ext uri="{FF2B5EF4-FFF2-40B4-BE49-F238E27FC236}">
-                <a16:creationId xmlns:a16="http://schemas.microsoft.com/office/drawing/2014/main" id="{1C276EDC-23A8-4119-A394-C1073D205E9E}"/>
+                <a16:creationId xmlns:a16="http://schemas.microsoft.com/office/drawing/2014/main" id="{1B897F9B-114B-40BA-B559-3F445F101C42}"/>
               </a:ext>
             </a:extLst>
           </p:cNvPr>
@@ -8116,7 +8116,7 @@
         </p:xfrm>
         <a:graphic xmlns:a="http://schemas.openxmlformats.org/drawingml/2006/main">
           <a:graphicData uri="http://schemas.openxmlformats.org/drawingml/2006/chart">
-            <c:chart xmlns:r="http://schemas.openxmlformats.org/officeDocument/2006/relationships" xmlns:c="http://schemas.openxmlformats.org/drawingml/2006/chart" r:id="Rd5bf6b5a9dfb415c"/>
+            <c:chart xmlns:r="http://schemas.openxmlformats.org/officeDocument/2006/relationships" xmlns:c="http://schemas.openxmlformats.org/drawingml/2006/chart" r:id="R31e49b6140544487"/>
           </a:graphicData>
         </a:graphic>
       </p:graphicFrame>
@@ -8125,7 +8125,7 @@
           <p:cNvPr id="5" name="">
             <a:extLst xmlns:a="http://schemas.openxmlformats.org/drawingml/2006/main">
               <a:ext uri="{FF2B5EF4-FFF2-40B4-BE49-F238E27FC236}">
-                <a16:creationId xmlns:a16="http://schemas.microsoft.com/office/drawing/2014/main" id="{CA40FC93-EE1D-48C6-8362-1F3D1A7F1EC7}"/>
+                <a16:creationId xmlns:a16="http://schemas.microsoft.com/office/drawing/2014/main" id="{66452DED-027F-44EC-969C-92DDCD586373}"/>
               </a:ext>
             </a:extLst>
           </p:cNvPr>
@@ -8182,7 +8182,7 @@
           <p:cNvPr id="6" name="">
             <a:extLst xmlns:a="http://schemas.openxmlformats.org/drawingml/2006/main">
               <a:ext uri="{FF2B5EF4-FFF2-40B4-BE49-F238E27FC236}">
-                <a16:creationId xmlns:a16="http://schemas.microsoft.com/office/drawing/2014/main" id="{1E65D55B-3F22-4655-A6BE-D38AD5671B41}"/>
+                <a16:creationId xmlns:a16="http://schemas.microsoft.com/office/drawing/2014/main" id="{AB34A88B-2E65-401B-9006-C14DA4AD45EF}"/>
               </a:ext>
             </a:extLst>
           </p:cNvPr>
@@ -8239,7 +8239,7 @@
           <p:cNvPr id="7" name="">
             <a:extLst xmlns:a="http://schemas.openxmlformats.org/drawingml/2006/main">
               <a:ext uri="{FF2B5EF4-FFF2-40B4-BE49-F238E27FC236}">
-                <a16:creationId xmlns:a16="http://schemas.microsoft.com/office/drawing/2014/main" id="{10CD2B41-6FCF-48E7-B04F-3B76B4EF8D7F}"/>
+                <a16:creationId xmlns:a16="http://schemas.microsoft.com/office/drawing/2014/main" id="{99D599F0-9554-4405-9780-3F1BA79C9E21}"/>
               </a:ext>
             </a:extLst>
           </p:cNvPr>
@@ -8294,7 +8294,7 @@
     </p:spTree>
     <p:extLst>
       <p:ext uri="{BB962C8B-B14F-4D97-AF65-F5344CB8AC3E}">
-        <p14:creationId xmlns:p14="http://schemas.microsoft.com/office/powerpoint/2010/main" val="634638304"/>
+        <p14:creationId xmlns:p14="http://schemas.microsoft.com/office/powerpoint/2010/main" val="2033853544"/>
       </p:ext>
     </p:extLst>
   </p:cSld>
@@ -8325,7 +8325,7 @@
           <p:cNvPr id="10" name="">
             <a:extLst xmlns:a="http://schemas.openxmlformats.org/drawingml/2006/main">
               <a:ext uri="{FF2B5EF4-FFF2-40B4-BE49-F238E27FC236}">
-                <a16:creationId xmlns:a16="http://schemas.microsoft.com/office/drawing/2014/main" id="{16FF8D49-E685-4783-8474-FEA04C3EC50F}"/>
+                <a16:creationId xmlns:a16="http://schemas.microsoft.com/office/drawing/2014/main" id="{971EAAA2-4496-4AA0-8FD3-A7F5E0CCA556}"/>
               </a:ext>
             </a:extLst>
           </p:cNvPr>
@@ -8372,7 +8372,7 @@
                 <a:ea typeface="Aptos"/>
                 <a:cs typeface="Aptos"/>
               </a:rPr>
-              <a:t>Final physical simulation: 129,600 runs</a:t>
+              <a:t>Corrected physical simulation: 129,600 runs</a:t>
             </a:r>
           </a:p>
         </p:txBody>
@@ -8382,7 +8382,7 @@
           <p:cNvPr id="2" name="">
             <a:extLst xmlns:a="http://schemas.openxmlformats.org/drawingml/2006/main">
               <a:ext uri="{FF2B5EF4-FFF2-40B4-BE49-F238E27FC236}">
-                <a16:creationId xmlns:a16="http://schemas.microsoft.com/office/drawing/2014/main" id="{DB1F69A9-EAAE-42A5-9EF1-1E459867442A}"/>
+                <a16:creationId xmlns:a16="http://schemas.microsoft.com/office/drawing/2014/main" id="{EDC3C074-6D4C-468D-970C-8F0C1BE2D048}"/>
               </a:ext>
             </a:extLst>
           </p:cNvPr>
@@ -8412,7 +8412,7 @@
           <p:cNvPr id="3" name="">
             <a:extLst xmlns:a="http://schemas.openxmlformats.org/drawingml/2006/main">
               <a:ext uri="{FF2B5EF4-FFF2-40B4-BE49-F238E27FC236}">
-                <a16:creationId xmlns:a16="http://schemas.microsoft.com/office/drawing/2014/main" id="{05776896-9AAB-4BD7-87D4-A701BA8E0A88}"/>
+                <a16:creationId xmlns:a16="http://schemas.microsoft.com/office/drawing/2014/main" id="{573C5ADD-2876-4E72-B8A3-F89B29C13F9B}"/>
               </a:ext>
             </a:extLst>
           </p:cNvPr>
@@ -8476,7 +8476,7 @@
         </p:xfrm>
         <a:graphic xmlns:a="http://schemas.openxmlformats.org/drawingml/2006/main">
           <a:graphicData uri="http://schemas.openxmlformats.org/drawingml/2006/chart">
-            <c:chart xmlns:r="http://schemas.openxmlformats.org/officeDocument/2006/relationships" xmlns:c="http://schemas.openxmlformats.org/drawingml/2006/chart" r:id="R2faf338fcbd6419e"/>
+            <c:chart xmlns:r="http://schemas.openxmlformats.org/officeDocument/2006/relationships" xmlns:c="http://schemas.openxmlformats.org/drawingml/2006/chart" r:id="R1f82885bfe8f4f5d"/>
           </a:graphicData>
         </a:graphic>
       </p:graphicFrame>
@@ -8485,7 +8485,7 @@
           <p:cNvPr id="5" name="">
             <a:extLst xmlns:a="http://schemas.openxmlformats.org/drawingml/2006/main">
               <a:ext uri="{FF2B5EF4-FFF2-40B4-BE49-F238E27FC236}">
-                <a16:creationId xmlns:a16="http://schemas.microsoft.com/office/drawing/2014/main" id="{B08E7817-C47F-430A-ADAC-5D9C6072FFD7}"/>
+                <a16:creationId xmlns:a16="http://schemas.microsoft.com/office/drawing/2014/main" id="{B9A3C4AD-DBA4-4FA2-9CA2-D694832407DF}"/>
               </a:ext>
             </a:extLst>
           </p:cNvPr>
@@ -8542,7 +8542,7 @@
           <p:cNvPr id="6" name="">
             <a:extLst xmlns:a="http://schemas.openxmlformats.org/drawingml/2006/main">
               <a:ext uri="{FF2B5EF4-FFF2-40B4-BE49-F238E27FC236}">
-                <a16:creationId xmlns:a16="http://schemas.microsoft.com/office/drawing/2014/main" id="{6FC13FD3-4333-4F1C-8346-2C874088ADBA}"/>
+                <a16:creationId xmlns:a16="http://schemas.microsoft.com/office/drawing/2014/main" id="{FF26DC73-46BD-4BBB-9A70-1479AE1F57E3}"/>
               </a:ext>
             </a:extLst>
           </p:cNvPr>
@@ -8599,7 +8599,7 @@
           <p:cNvPr id="7" name="">
             <a:extLst xmlns:a="http://schemas.openxmlformats.org/drawingml/2006/main">
               <a:ext uri="{FF2B5EF4-FFF2-40B4-BE49-F238E27FC236}">
-                <a16:creationId xmlns:a16="http://schemas.microsoft.com/office/drawing/2014/main" id="{E5F7C314-C81A-4695-958F-37A8ED2FC780}"/>
+                <a16:creationId xmlns:a16="http://schemas.microsoft.com/office/drawing/2014/main" id="{15916386-282F-4BF0-8565-F65398562C8D}"/>
               </a:ext>
             </a:extLst>
           </p:cNvPr>
@@ -8610,8 +8610,8 @@
         </p:nvSpPr>
         <p:spPr>
           <a:xfrm xmlns:a="http://schemas.openxmlformats.org/drawingml/2006/main">
-            <a:off x="8477250" y="3238500"/>
-            <a:ext cx="2667000" cy="952500"/>
+            <a:off x="8477250" y="3105150"/>
+            <a:ext cx="2667000" cy="990600"/>
           </a:xfrm>
           <a:prstGeom xmlns:a="http://schemas.openxmlformats.org/drawingml/2006/main" prst="rect">
             <a:avLst/>
@@ -8646,7 +8646,7 @@
                 <a:ea typeface="Aptos"/>
                 <a:cs typeface="Aptos"/>
               </a:rPr>
-              <a:t>At 50 tests: 99.64% actual overlap, 0.00% false overlap.</a:t>
+              <a:t>At 50 tests: 99.70% actual overlap, 0.009% false overlap.</a:t>
             </a:r>
           </a:p>
         </p:txBody>
@@ -8656,7 +8656,7 @@
           <p:cNvPr id="8" name="">
             <a:extLst xmlns:a="http://schemas.openxmlformats.org/drawingml/2006/main">
               <a:ext uri="{FF2B5EF4-FFF2-40B4-BE49-F238E27FC236}">
-                <a16:creationId xmlns:a16="http://schemas.microsoft.com/office/drawing/2014/main" id="{0B8C2580-167B-4EBB-A4AC-264AB279FD5A}"/>
+                <a16:creationId xmlns:a16="http://schemas.microsoft.com/office/drawing/2014/main" id="{576ADC13-F0E5-4938-859E-763E85E6F2DA}"/>
               </a:ext>
             </a:extLst>
           </p:cNvPr>
@@ -8667,8 +8667,8 @@
         </p:nvSpPr>
         <p:spPr>
           <a:xfrm xmlns:a="http://schemas.openxmlformats.org/drawingml/2006/main">
-            <a:off x="8477250" y="4533900"/>
-            <a:ext cx="2667000" cy="876300"/>
+            <a:off x="8477250" y="4381500"/>
+            <a:ext cx="2667000" cy="1123950"/>
           </a:xfrm>
           <a:prstGeom xmlns:a="http://schemas.openxmlformats.org/drawingml/2006/main" prst="rect">
             <a:avLst/>
@@ -8685,7 +8685,7 @@
           <a:lstStyle xmlns:a="http://schemas.openxmlformats.org/drawingml/2006/main"/>
           <a:p xmlns:a="http://schemas.openxmlformats.org/drawingml/2006/main">
             <a:pPr algn="l">
-              <a:defRPr sz="1350" b="0">
+              <a:defRPr sz="1275" b="0">
                 <a:solidFill>
                   <a:srgbClr val="526775"/>
                 </a:solidFill>
@@ -8695,7 +8695,7 @@
               </a:defRPr>
             </a:pPr>
             <a:r>
-              <a:rPr sz="1350" b="0">
+              <a:rPr sz="1275" b="0">
                 <a:solidFill>
                   <a:srgbClr val="526775"/>
                 </a:solidFill>
@@ -8703,7 +8703,7 @@
                 <a:ea typeface="Aptos"/>
                 <a:cs typeface="Aptos"/>
               </a:rPr>
-              <a:t>Middle and width RMSE stayed unchanged at the displayed precision.</a:t>
+              <a:t>These corrected values replace the earlier simulation, which used the requested gap—not the actual built gap—to decide the outcome.</a:t>
             </a:r>
           </a:p>
         </p:txBody>
@@ -8713,7 +8713,7 @@
           <p:cNvPr id="9" name="">
             <a:extLst xmlns:a="http://schemas.openxmlformats.org/drawingml/2006/main">
               <a:ext uri="{FF2B5EF4-FFF2-40B4-BE49-F238E27FC236}">
-                <a16:creationId xmlns:a16="http://schemas.microsoft.com/office/drawing/2014/main" id="{CC8929FF-D72C-4232-B675-971053389944}"/>
+                <a16:creationId xmlns:a16="http://schemas.microsoft.com/office/drawing/2014/main" id="{5E7531CF-7BF6-4C02-8634-69011511406F}"/>
               </a:ext>
             </a:extLst>
           </p:cNvPr>
@@ -8760,7 +8760,7 @@
                 <a:ea typeface="Aptos"/>
                 <a:cs typeface="Aptos"/>
               </a:rPr>
-              <a:t>432 settings × 300 repetitions</a:t>
+              <a:t>432 scenarios × 300 repetitions · outcome uses actual built gap</a:t>
             </a:r>
           </a:p>
         </p:txBody>
@@ -8768,7 +8768,7 @@
     </p:spTree>
     <p:extLst>
       <p:ext uri="{BB962C8B-B14F-4D97-AF65-F5344CB8AC3E}">
-        <p14:creationId xmlns:p14="http://schemas.microsoft.com/office/powerpoint/2010/main" val="1420731238"/>
+        <p14:creationId xmlns:p14="http://schemas.microsoft.com/office/powerpoint/2010/main" val="1219087172"/>
       </p:ext>
     </p:extLst>
   </p:cSld>
@@ -8799,7 +8799,7 @@
           <p:cNvPr id="12" name="">
             <a:extLst xmlns:a="http://schemas.openxmlformats.org/drawingml/2006/main">
               <a:ext uri="{FF2B5EF4-FFF2-40B4-BE49-F238E27FC236}">
-                <a16:creationId xmlns:a16="http://schemas.microsoft.com/office/drawing/2014/main" id="{EE380027-8160-4E02-9939-7F32688F44F5}"/>
+                <a16:creationId xmlns:a16="http://schemas.microsoft.com/office/drawing/2014/main" id="{E0EF46F7-FF4B-43E5-9CBE-F04BA46DEA16}"/>
               </a:ext>
             </a:extLst>
           </p:cNvPr>
@@ -8856,7 +8856,7 @@
           <p:cNvPr id="2" name="">
             <a:extLst xmlns:a="http://schemas.openxmlformats.org/drawingml/2006/main">
               <a:ext uri="{FF2B5EF4-FFF2-40B4-BE49-F238E27FC236}">
-                <a16:creationId xmlns:a16="http://schemas.microsoft.com/office/drawing/2014/main" id="{44856B49-4AD4-461E-8F4D-A3F087D70714}"/>
+                <a16:creationId xmlns:a16="http://schemas.microsoft.com/office/drawing/2014/main" id="{AB51A13E-0EBE-4CBA-B13A-C25D291346D2}"/>
               </a:ext>
             </a:extLst>
           </p:cNvPr>
@@ -8886,7 +8886,7 @@
           <p:cNvPr id="3" name="">
             <a:extLst xmlns:a="http://schemas.openxmlformats.org/drawingml/2006/main">
               <a:ext uri="{FF2B5EF4-FFF2-40B4-BE49-F238E27FC236}">
-                <a16:creationId xmlns:a16="http://schemas.microsoft.com/office/drawing/2014/main" id="{CEDA47A9-1AE5-4CA2-B9D6-E7386BB4F300}"/>
+                <a16:creationId xmlns:a16="http://schemas.microsoft.com/office/drawing/2014/main" id="{F85782B3-EC01-4772-8740-1EE1D01420BB}"/>
               </a:ext>
             </a:extLst>
           </p:cNvPr>
@@ -8947,7 +8947,7 @@
           <p:nvPr/>
         </p:nvPicPr>
         <p:blipFill>
-          <a:blip xmlns:r="http://schemas.openxmlformats.org/officeDocument/2006/relationships" xmlns:a="http://schemas.openxmlformats.org/drawingml/2006/main" r:embed="Rcb280737da56484c"/>
+          <a:blip xmlns:r="http://schemas.openxmlformats.org/officeDocument/2006/relationships" xmlns:a="http://schemas.openxmlformats.org/drawingml/2006/main" r:embed="R3938e41215e9459f"/>
           <a:stretch xmlns:a="http://schemas.openxmlformats.org/drawingml/2006/main"/>
         </p:blipFill>
         <p:spPr>
@@ -8965,7 +8965,7 @@
           <p:cNvPr id="5" name="">
             <a:extLst xmlns:a="http://schemas.openxmlformats.org/drawingml/2006/main">
               <a:ext uri="{FF2B5EF4-FFF2-40B4-BE49-F238E27FC236}">
-                <a16:creationId xmlns:a16="http://schemas.microsoft.com/office/drawing/2014/main" id="{2FC36832-48C8-4AAC-B2A4-BAEB045E5E3F}"/>
+                <a16:creationId xmlns:a16="http://schemas.microsoft.com/office/drawing/2014/main" id="{AE4B057E-6032-4FB5-A06D-2ECDF5530735}"/>
               </a:ext>
             </a:extLst>
           </p:cNvPr>
@@ -9022,7 +9022,7 @@
           <p:cNvPr id="6" name="">
             <a:extLst xmlns:a="http://schemas.openxmlformats.org/drawingml/2006/main">
               <a:ext uri="{FF2B5EF4-FFF2-40B4-BE49-F238E27FC236}">
-                <a16:creationId xmlns:a16="http://schemas.microsoft.com/office/drawing/2014/main" id="{3CDDAB4A-40CC-40B4-87B7-468117878DC4}"/>
+                <a16:creationId xmlns:a16="http://schemas.microsoft.com/office/drawing/2014/main" id="{261788D2-4047-4FD1-A7CE-FC2775D0513D}"/>
               </a:ext>
             </a:extLst>
           </p:cNvPr>
@@ -9079,7 +9079,7 @@
           <p:cNvPr id="7" name="">
             <a:extLst xmlns:a="http://schemas.openxmlformats.org/drawingml/2006/main">
               <a:ext uri="{FF2B5EF4-FFF2-40B4-BE49-F238E27FC236}">
-                <a16:creationId xmlns:a16="http://schemas.microsoft.com/office/drawing/2014/main" id="{4AC4B8AA-D082-4E1D-9B63-747FA8899038}"/>
+                <a16:creationId xmlns:a16="http://schemas.microsoft.com/office/drawing/2014/main" id="{67A087E0-8CAE-42A6-8FA3-893961D65ADB}"/>
               </a:ext>
             </a:extLst>
           </p:cNvPr>
@@ -9136,7 +9136,7 @@
           <p:cNvPr id="8" name="">
             <a:extLst xmlns:a="http://schemas.openxmlformats.org/drawingml/2006/main">
               <a:ext uri="{FF2B5EF4-FFF2-40B4-BE49-F238E27FC236}">
-                <a16:creationId xmlns:a16="http://schemas.microsoft.com/office/drawing/2014/main" id="{787B7374-E8F2-4492-81D0-D01DC5FE9021}"/>
+                <a16:creationId xmlns:a16="http://schemas.microsoft.com/office/drawing/2014/main" id="{FE79E8FE-0D71-453B-9616-E80DDB89BE3E}"/>
               </a:ext>
             </a:extLst>
           </p:cNvPr>
@@ -9193,7 +9193,7 @@
           <p:cNvPr id="9" name="">
             <a:extLst xmlns:a="http://schemas.openxmlformats.org/drawingml/2006/main">
               <a:ext uri="{FF2B5EF4-FFF2-40B4-BE49-F238E27FC236}">
-                <a16:creationId xmlns:a16="http://schemas.microsoft.com/office/drawing/2014/main" id="{E5ED2C55-BD7B-4011-B38D-497717F96B34}"/>
+                <a16:creationId xmlns:a16="http://schemas.microsoft.com/office/drawing/2014/main" id="{7451898A-8180-4617-AF7E-45A1806CDBCE}"/>
               </a:ext>
             </a:extLst>
           </p:cNvPr>
@@ -9250,7 +9250,7 @@
           <p:cNvPr id="10" name="">
             <a:extLst xmlns:a="http://schemas.openxmlformats.org/drawingml/2006/main">
               <a:ext uri="{FF2B5EF4-FFF2-40B4-BE49-F238E27FC236}">
-                <a16:creationId xmlns:a16="http://schemas.microsoft.com/office/drawing/2014/main" id="{736B0919-0479-4349-B827-6E407631DB9C}"/>
+                <a16:creationId xmlns:a16="http://schemas.microsoft.com/office/drawing/2014/main" id="{D1C8AAAF-295C-401D-939C-86DB92F3424D}"/>
               </a:ext>
             </a:extLst>
           </p:cNvPr>
@@ -9307,7 +9307,7 @@
           <p:cNvPr id="11" name="">
             <a:extLst xmlns:a="http://schemas.openxmlformats.org/drawingml/2006/main">
               <a:ext uri="{FF2B5EF4-FFF2-40B4-BE49-F238E27FC236}">
-                <a16:creationId xmlns:a16="http://schemas.microsoft.com/office/drawing/2014/main" id="{5AA357DD-6590-4756-9956-9ECAFBB1E699}"/>
+                <a16:creationId xmlns:a16="http://schemas.microsoft.com/office/drawing/2014/main" id="{9548C602-95A7-4A98-949B-5534E98DC081}"/>
               </a:ext>
             </a:extLst>
           </p:cNvPr>
@@ -9362,7 +9362,7 @@
     </p:spTree>
     <p:extLst>
       <p:ext uri="{BB962C8B-B14F-4D97-AF65-F5344CB8AC3E}">
-        <p14:creationId xmlns:p14="http://schemas.microsoft.com/office/powerpoint/2010/main" val="685787314"/>
+        <p14:creationId xmlns:p14="http://schemas.microsoft.com/office/powerpoint/2010/main" val="423678801"/>
       </p:ext>
     </p:extLst>
   </p:cSld>
@@ -9393,7 +9393,7 @@
           <p:cNvPr id="11" name="">
             <a:extLst xmlns:a="http://schemas.openxmlformats.org/drawingml/2006/main">
               <a:ext uri="{FF2B5EF4-FFF2-40B4-BE49-F238E27FC236}">
-                <a16:creationId xmlns:a16="http://schemas.microsoft.com/office/drawing/2014/main" id="{39DC2B0F-A538-442A-8A2D-6A319226026E}"/>
+                <a16:creationId xmlns:a16="http://schemas.microsoft.com/office/drawing/2014/main" id="{356579CF-8FCD-4439-8941-C06E6BE1F182}"/>
               </a:ext>
             </a:extLst>
           </p:cNvPr>
@@ -9450,7 +9450,7 @@
           <p:cNvPr id="2" name="">
             <a:extLst xmlns:a="http://schemas.openxmlformats.org/drawingml/2006/main">
               <a:ext uri="{FF2B5EF4-FFF2-40B4-BE49-F238E27FC236}">
-                <a16:creationId xmlns:a16="http://schemas.microsoft.com/office/drawing/2014/main" id="{CA55ADCB-C5FD-499A-B373-696835881E6D}"/>
+                <a16:creationId xmlns:a16="http://schemas.microsoft.com/office/drawing/2014/main" id="{3E593E73-FC61-4E11-AFD5-E8D687454FE7}"/>
               </a:ext>
             </a:extLst>
           </p:cNvPr>
@@ -9480,7 +9480,7 @@
           <p:cNvPr id="3" name="">
             <a:extLst xmlns:a="http://schemas.openxmlformats.org/drawingml/2006/main">
               <a:ext uri="{FF2B5EF4-FFF2-40B4-BE49-F238E27FC236}">
-                <a16:creationId xmlns:a16="http://schemas.microsoft.com/office/drawing/2014/main" id="{A1C8A41F-F652-4F57-BA7D-6AF69D0E9CDC}"/>
+                <a16:creationId xmlns:a16="http://schemas.microsoft.com/office/drawing/2014/main" id="{0DB8F814-04B9-47FA-BF50-7654676047FD}"/>
               </a:ext>
             </a:extLst>
           </p:cNvPr>
@@ -9541,7 +9541,7 @@
           <p:nvPr/>
         </p:nvPicPr>
         <p:blipFill>
-          <a:blip xmlns:r="http://schemas.openxmlformats.org/officeDocument/2006/relationships" xmlns:a="http://schemas.openxmlformats.org/drawingml/2006/main" r:embed="R6debc727a53c4e3c"/>
+          <a:blip xmlns:r="http://schemas.openxmlformats.org/officeDocument/2006/relationships" xmlns:a="http://schemas.openxmlformats.org/drawingml/2006/main" r:embed="R5756043aa1e94ad5"/>
           <a:stretch xmlns:a="http://schemas.openxmlformats.org/drawingml/2006/main"/>
         </p:blipFill>
         <p:spPr>
@@ -9563,7 +9563,7 @@
           <p:nvPr/>
         </p:nvPicPr>
         <p:blipFill>
-          <a:blip xmlns:r="http://schemas.openxmlformats.org/officeDocument/2006/relationships" xmlns:a="http://schemas.openxmlformats.org/drawingml/2006/main" r:embed="Rb8475d24f4004d09"/>
+          <a:blip xmlns:r="http://schemas.openxmlformats.org/officeDocument/2006/relationships" xmlns:a="http://schemas.openxmlformats.org/drawingml/2006/main" r:embed="Rf21637a3abe64e46"/>
           <a:stretch xmlns:a="http://schemas.openxmlformats.org/drawingml/2006/main"/>
         </p:blipFill>
         <p:spPr>
@@ -9585,7 +9585,7 @@
           <p:nvPr/>
         </p:nvPicPr>
         <p:blipFill>
-          <a:blip xmlns:r="http://schemas.openxmlformats.org/officeDocument/2006/relationships" xmlns:a="http://schemas.openxmlformats.org/drawingml/2006/main" r:embed="Re6e60c810d094a84"/>
+          <a:blip xmlns:r="http://schemas.openxmlformats.org/officeDocument/2006/relationships" xmlns:a="http://schemas.openxmlformats.org/drawingml/2006/main" r:embed="R9bd4c31f42924c1d"/>
           <a:stretch xmlns:a="http://schemas.openxmlformats.org/drawingml/2006/main"/>
         </p:blipFill>
         <p:spPr>
@@ -9603,7 +9603,7 @@
           <p:cNvPr id="7" name="">
             <a:extLst xmlns:a="http://schemas.openxmlformats.org/drawingml/2006/main">
               <a:ext uri="{FF2B5EF4-FFF2-40B4-BE49-F238E27FC236}">
-                <a16:creationId xmlns:a16="http://schemas.microsoft.com/office/drawing/2014/main" id="{551FD1A1-516D-4D1E-A682-0C3AE0A8D4E7}"/>
+                <a16:creationId xmlns:a16="http://schemas.microsoft.com/office/drawing/2014/main" id="{C885E577-8501-4A1A-9181-AB1919102234}"/>
               </a:ext>
             </a:extLst>
           </p:cNvPr>
@@ -9660,7 +9660,7 @@
           <p:cNvPr id="8" name="">
             <a:extLst xmlns:a="http://schemas.openxmlformats.org/drawingml/2006/main">
               <a:ext uri="{FF2B5EF4-FFF2-40B4-BE49-F238E27FC236}">
-                <a16:creationId xmlns:a16="http://schemas.microsoft.com/office/drawing/2014/main" id="{6372D608-C81F-4E57-B292-9BA904602E1F}"/>
+                <a16:creationId xmlns:a16="http://schemas.microsoft.com/office/drawing/2014/main" id="{F8263AED-1A3B-49E3-86A0-00C1CB8DEC5A}"/>
               </a:ext>
             </a:extLst>
           </p:cNvPr>
@@ -9717,7 +9717,7 @@
           <p:cNvPr id="9" name="">
             <a:extLst xmlns:a="http://schemas.openxmlformats.org/drawingml/2006/main">
               <a:ext uri="{FF2B5EF4-FFF2-40B4-BE49-F238E27FC236}">
-                <a16:creationId xmlns:a16="http://schemas.microsoft.com/office/drawing/2014/main" id="{303BA70F-8979-4F2D-8487-E0E27F6DA58E}"/>
+                <a16:creationId xmlns:a16="http://schemas.microsoft.com/office/drawing/2014/main" id="{290DB695-BDDC-4453-81ED-B5D7304DFCAA}"/>
               </a:ext>
             </a:extLst>
           </p:cNvPr>
@@ -9774,7 +9774,7 @@
           <p:cNvPr id="10" name="">
             <a:extLst xmlns:a="http://schemas.openxmlformats.org/drawingml/2006/main">
               <a:ext uri="{FF2B5EF4-FFF2-40B4-BE49-F238E27FC236}">
-                <a16:creationId xmlns:a16="http://schemas.microsoft.com/office/drawing/2014/main" id="{7C657C45-8278-48FC-A43D-636AB09838DC}"/>
+                <a16:creationId xmlns:a16="http://schemas.microsoft.com/office/drawing/2014/main" id="{06CC8EEB-0BFC-4071-A50B-54EDAF696270}"/>
               </a:ext>
             </a:extLst>
           </p:cNvPr>
@@ -9829,7 +9829,7 @@
     </p:spTree>
     <p:extLst>
       <p:ext uri="{BB962C8B-B14F-4D97-AF65-F5344CB8AC3E}">
-        <p14:creationId xmlns:p14="http://schemas.microsoft.com/office/powerpoint/2010/main" val="1387297629"/>
+        <p14:creationId xmlns:p14="http://schemas.microsoft.com/office/powerpoint/2010/main" val="98658728"/>
       </p:ext>
     </p:extLst>
   </p:cSld>

</xml_diff>

<commit_message>
Finalize physical gap rules and v1.9 delivery
</commit_message>
<xml_diff>
--- a/delivery/Neyer_Gap_Test_v1_9_Presentation.pptx
+++ b/delivery/Neyer_Gap_Test_v1_9_Presentation.pptx
@@ -2,24 +2,24 @@
 <file path=ppt/presentation.xml><?xml version="1.0" encoding="utf-8"?>
 <p:presentation xmlns:p="http://schemas.openxmlformats.org/presentationml/2006/main">
   <p:sldMasterIdLst>
-    <p:sldMasterId xmlns:r="http://schemas.openxmlformats.org/officeDocument/2006/relationships" id="2147483648" r:id="R29d268bc72a44e5a"/>
+    <p:sldMasterId xmlns:r="http://schemas.openxmlformats.org/officeDocument/2006/relationships" id="2147483648" r:id="R719b1894d626412c"/>
   </p:sldMasterIdLst>
   <p:notesMasterIdLst>
-    <p:notesMasterId xmlns:r="http://schemas.openxmlformats.org/officeDocument/2006/relationships" r:id="R42e501fb7476489d"/>
+    <p:notesMasterId xmlns:r="http://schemas.openxmlformats.org/officeDocument/2006/relationships" r:id="R7bb2545a7d884fb5"/>
   </p:notesMasterIdLst>
   <p:sldIdLst>
-    <p:sldId xmlns:r="http://schemas.openxmlformats.org/officeDocument/2006/relationships" id="256" r:id="R48bae8b675f244dc"/>
-    <p:sldId xmlns:r="http://schemas.openxmlformats.org/officeDocument/2006/relationships" id="257" r:id="R5fba481eead34301"/>
-    <p:sldId xmlns:r="http://schemas.openxmlformats.org/officeDocument/2006/relationships" id="258" r:id="R3de876aedcf74281"/>
-    <p:sldId xmlns:r="http://schemas.openxmlformats.org/officeDocument/2006/relationships" id="259" r:id="Rc907133fa73b4e9b"/>
-    <p:sldId xmlns:r="http://schemas.openxmlformats.org/officeDocument/2006/relationships" id="260" r:id="R703d525032f746a9"/>
-    <p:sldId xmlns:r="http://schemas.openxmlformats.org/officeDocument/2006/relationships" id="261" r:id="R6540d934b37844cd"/>
-    <p:sldId xmlns:r="http://schemas.openxmlformats.org/officeDocument/2006/relationships" id="262" r:id="R247e035d9a98424f"/>
-    <p:sldId xmlns:r="http://schemas.openxmlformats.org/officeDocument/2006/relationships" id="263" r:id="Rc0e0f702512b42bb"/>
-    <p:sldId xmlns:r="http://schemas.openxmlformats.org/officeDocument/2006/relationships" id="264" r:id="R790f9e2f764648dd"/>
-    <p:sldId xmlns:r="http://schemas.openxmlformats.org/officeDocument/2006/relationships" id="265" r:id="R28c46bacc460496d"/>
-    <p:sldId xmlns:r="http://schemas.openxmlformats.org/officeDocument/2006/relationships" id="266" r:id="Rc7c443ae85924335"/>
-    <p:sldId xmlns:r="http://schemas.openxmlformats.org/officeDocument/2006/relationships" id="267" r:id="Rada51f53d1d84261"/>
+    <p:sldId xmlns:r="http://schemas.openxmlformats.org/officeDocument/2006/relationships" id="256" r:id="Ra54cad17e97c4fb6"/>
+    <p:sldId xmlns:r="http://schemas.openxmlformats.org/officeDocument/2006/relationships" id="257" r:id="Rb72a3fc5d8ad4611"/>
+    <p:sldId xmlns:r="http://schemas.openxmlformats.org/officeDocument/2006/relationships" id="258" r:id="R829b378f6d11473d"/>
+    <p:sldId xmlns:r="http://schemas.openxmlformats.org/officeDocument/2006/relationships" id="259" r:id="Rbb58a09a7a364e71"/>
+    <p:sldId xmlns:r="http://schemas.openxmlformats.org/officeDocument/2006/relationships" id="260" r:id="R8262afe492f74049"/>
+    <p:sldId xmlns:r="http://schemas.openxmlformats.org/officeDocument/2006/relationships" id="261" r:id="R0fe2a9a7fc8848c5"/>
+    <p:sldId xmlns:r="http://schemas.openxmlformats.org/officeDocument/2006/relationships" id="262" r:id="R7f98eee19c8946f5"/>
+    <p:sldId xmlns:r="http://schemas.openxmlformats.org/officeDocument/2006/relationships" id="263" r:id="Rd1e8fdb8a7e744c1"/>
+    <p:sldId xmlns:r="http://schemas.openxmlformats.org/officeDocument/2006/relationships" id="264" r:id="R84626b49660e4b80"/>
+    <p:sldId xmlns:r="http://schemas.openxmlformats.org/officeDocument/2006/relationships" id="265" r:id="Re08c5b5e86544301"/>
+    <p:sldId xmlns:r="http://schemas.openxmlformats.org/officeDocument/2006/relationships" id="266" r:id="R09711567f4b3409e"/>
+    <p:sldId xmlns:r="http://schemas.openxmlformats.org/officeDocument/2006/relationships" id="267" r:id="Rfdaea3830a884d89"/>
   </p:sldIdLst>
   <p:sldSz cx="12192000" cy="6858000"/>
   <p:notesSz cx="6858000" cy="9144000"/>
@@ -1243,7 +1243,7 @@
   </p:cSld>
   <p:clrMap bg1="lt1" tx1="dk1" bg2="lt2" tx2="dk2" accent1="accent1" accent2="accent2" accent3="accent3" accent4="accent4" accent5="accent5" accent6="accent6" hlink="hlink" folHlink="folHlink"/>
   <p:sldLayoutIdLst>
-    <p:sldLayoutId xmlns:r="http://schemas.openxmlformats.org/officeDocument/2006/relationships" id="2147483649" r:id="Re2703dbb4b684e32"/>
+    <p:sldLayoutId xmlns:r="http://schemas.openxmlformats.org/officeDocument/2006/relationships" id="2147483649" r:id="Rd4b57ddd6fac4167"/>
   </p:sldLayoutIdLst>
   <p:txStyles>
     <p:titleStyle>
@@ -2057,7 +2057,7 @@
                     <a:ea typeface="Aptos"/>
                     <a:cs typeface="Aptos"/>
                   </a:rPr>
-                  <a:t>Physical increment (mm)</a:t>
+                  <a:t>Usable gap step (mm)</a:t>
                 </a:r>
               </a:p>
             </c:rich>
@@ -2247,10 +2247,10 @@
                 <c:v>No floor</c:v>
               </c:pt>
               <c:pt idx="1">
-                <c:v>1 × increment</c:v>
+                <c:v>1 × resolution</c:v>
               </c:pt>
               <c:pt idx="2">
-                <c:v>2 × increment</c:v>
+                <c:v>2 × resolution</c:v>
               </c:pt>
             </c:strLit>
           </c:cat>
@@ -2288,10 +2288,10 @@
                 <c:v>No floor</c:v>
               </c:pt>
               <c:pt idx="1">
-                <c:v>1 × increment</c:v>
+                <c:v>1 × resolution</c:v>
               </c:pt>
               <c:pt idx="2">
-                <c:v>2 × increment</c:v>
+                <c:v>2 × resolution</c:v>
               </c:pt>
             </c:strLit>
           </c:cat>
@@ -2483,7 +2483,7 @@
           <p:cNvPr id="9" name="">
             <a:extLst xmlns:a="http://schemas.openxmlformats.org/drawingml/2006/main">
               <a:ext uri="{FF2B5EF4-FFF2-40B4-BE49-F238E27FC236}">
-                <a16:creationId xmlns:a16="http://schemas.microsoft.com/office/drawing/2014/main" id="{E51D57D5-36E6-47A8-8706-24B800BD8576}"/>
+                <a16:creationId xmlns:a16="http://schemas.microsoft.com/office/drawing/2014/main" id="{612B8BF2-D9B7-4D33-B5A9-8A70AFF108C6}"/>
               </a:ext>
             </a:extLst>
           </p:cNvPr>
@@ -2540,7 +2540,7 @@
           <p:cNvPr id="2" name="">
             <a:extLst xmlns:a="http://schemas.openxmlformats.org/drawingml/2006/main">
               <a:ext uri="{FF2B5EF4-FFF2-40B4-BE49-F238E27FC236}">
-                <a16:creationId xmlns:a16="http://schemas.microsoft.com/office/drawing/2014/main" id="{37786D56-7E2B-46E3-B759-B076BD0C66C1}"/>
+                <a16:creationId xmlns:a16="http://schemas.microsoft.com/office/drawing/2014/main" id="{0A267323-D5D2-48F5-AFE2-D0AA4FC1A434}"/>
               </a:ext>
             </a:extLst>
           </p:cNvPr>
@@ -2597,7 +2597,7 @@
           <p:cNvPr id="3" name="">
             <a:extLst xmlns:a="http://schemas.openxmlformats.org/drawingml/2006/main">
               <a:ext uri="{FF2B5EF4-FFF2-40B4-BE49-F238E27FC236}">
-                <a16:creationId xmlns:a16="http://schemas.microsoft.com/office/drawing/2014/main" id="{3577C40A-B74A-4542-9A79-541D656A6BF4}"/>
+                <a16:creationId xmlns:a16="http://schemas.microsoft.com/office/drawing/2014/main" id="{62DBC00E-92BB-4463-96D6-0701098F69B1}"/>
               </a:ext>
             </a:extLst>
           </p:cNvPr>
@@ -2627,7 +2627,7 @@
           <p:cNvPr id="4" name="">
             <a:extLst xmlns:a="http://schemas.openxmlformats.org/drawingml/2006/main">
               <a:ext uri="{FF2B5EF4-FFF2-40B4-BE49-F238E27FC236}">
-                <a16:creationId xmlns:a16="http://schemas.microsoft.com/office/drawing/2014/main" id="{3482B599-9700-4A5A-9951-574675C66AAF}"/>
+                <a16:creationId xmlns:a16="http://schemas.microsoft.com/office/drawing/2014/main" id="{DBBD63D1-5603-46A9-8FCB-0CF27F7D27C5}"/>
               </a:ext>
             </a:extLst>
           </p:cNvPr>
@@ -2657,7 +2657,7 @@
           <p:cNvPr id="5" name="">
             <a:extLst xmlns:a="http://schemas.openxmlformats.org/drawingml/2006/main">
               <a:ext uri="{FF2B5EF4-FFF2-40B4-BE49-F238E27FC236}">
-                <a16:creationId xmlns:a16="http://schemas.microsoft.com/office/drawing/2014/main" id="{43932137-C6BA-40D1-AB45-E08A941DCC57}"/>
+                <a16:creationId xmlns:a16="http://schemas.microsoft.com/office/drawing/2014/main" id="{97FA9C53-6CC6-47C8-BC27-8B81BB44A550}"/>
               </a:ext>
             </a:extLst>
           </p:cNvPr>
@@ -2687,7 +2687,7 @@
           <p:cNvPr id="6" name="">
             <a:extLst xmlns:a="http://schemas.openxmlformats.org/drawingml/2006/main">
               <a:ext uri="{FF2B5EF4-FFF2-40B4-BE49-F238E27FC236}">
-                <a16:creationId xmlns:a16="http://schemas.microsoft.com/office/drawing/2014/main" id="{78C08BC5-4E84-4E8F-B7C6-1722B0914D0D}"/>
+                <a16:creationId xmlns:a16="http://schemas.microsoft.com/office/drawing/2014/main" id="{A11A25D8-FA40-4509-8988-CEF825009547}"/>
               </a:ext>
             </a:extLst>
           </p:cNvPr>
@@ -2744,7 +2744,7 @@
           <p:cNvPr id="7" name="">
             <a:extLst xmlns:a="http://schemas.openxmlformats.org/drawingml/2006/main">
               <a:ext uri="{FF2B5EF4-FFF2-40B4-BE49-F238E27FC236}">
-                <a16:creationId xmlns:a16="http://schemas.microsoft.com/office/drawing/2014/main" id="{9AD49418-6C72-4574-ACD7-682BF76FB017}"/>
+                <a16:creationId xmlns:a16="http://schemas.microsoft.com/office/drawing/2014/main" id="{271E46D7-AEAA-41D8-8DBD-DB37CF1E293C}"/>
               </a:ext>
             </a:extLst>
           </p:cNvPr>
@@ -2824,7 +2824,7 @@
           <p:cNvPr id="8" name="">
             <a:extLst xmlns:a="http://schemas.openxmlformats.org/drawingml/2006/main">
               <a:ext uri="{FF2B5EF4-FFF2-40B4-BE49-F238E27FC236}">
-                <a16:creationId xmlns:a16="http://schemas.microsoft.com/office/drawing/2014/main" id="{B3B44A24-D84D-498C-852C-972123D76944}"/>
+                <a16:creationId xmlns:a16="http://schemas.microsoft.com/office/drawing/2014/main" id="{3E532FFB-DA55-4D6C-8ADA-CBE26B981939}"/>
               </a:ext>
             </a:extLst>
           </p:cNvPr>
@@ -2879,7 +2879,7 @@
     </p:spTree>
     <p:extLst>
       <p:ext uri="{BB962C8B-B14F-4D97-AF65-F5344CB8AC3E}">
-        <p14:creationId xmlns:p14="http://schemas.microsoft.com/office/powerpoint/2010/main" val="158706680"/>
+        <p14:creationId xmlns:p14="http://schemas.microsoft.com/office/powerpoint/2010/main" val="1073236394"/>
       </p:ext>
     </p:extLst>
   </p:cSld>
@@ -2910,7 +2910,7 @@
           <p:cNvPr id="6" name="">
             <a:extLst xmlns:a="http://schemas.openxmlformats.org/drawingml/2006/main">
               <a:ext uri="{FF2B5EF4-FFF2-40B4-BE49-F238E27FC236}">
-                <a16:creationId xmlns:a16="http://schemas.microsoft.com/office/drawing/2014/main" id="{CC2E5342-56D7-4D99-941D-61DD3AB57B59}"/>
+                <a16:creationId xmlns:a16="http://schemas.microsoft.com/office/drawing/2014/main" id="{E8CC6150-E060-4BD1-A91B-F589E8753B5F}"/>
               </a:ext>
             </a:extLst>
           </p:cNvPr>
@@ -2967,7 +2967,7 @@
           <p:cNvPr id="2" name="">
             <a:extLst xmlns:a="http://schemas.openxmlformats.org/drawingml/2006/main">
               <a:ext uri="{FF2B5EF4-FFF2-40B4-BE49-F238E27FC236}">
-                <a16:creationId xmlns:a16="http://schemas.microsoft.com/office/drawing/2014/main" id="{27B95E04-376C-41FD-B035-86B11A5FE2ED}"/>
+                <a16:creationId xmlns:a16="http://schemas.microsoft.com/office/drawing/2014/main" id="{399C0D46-FE0F-4B52-AA9D-68EB06AA2E02}"/>
               </a:ext>
             </a:extLst>
           </p:cNvPr>
@@ -2997,7 +2997,7 @@
           <p:cNvPr id="3" name="">
             <a:extLst xmlns:a="http://schemas.openxmlformats.org/drawingml/2006/main">
               <a:ext uri="{FF2B5EF4-FFF2-40B4-BE49-F238E27FC236}">
-                <a16:creationId xmlns:a16="http://schemas.microsoft.com/office/drawing/2014/main" id="{F1042373-C06E-4AE2-B649-0FDE72519A79}"/>
+                <a16:creationId xmlns:a16="http://schemas.microsoft.com/office/drawing/2014/main" id="{C33ABFD6-0E33-4251-9856-B8DE68DDE3D9}"/>
               </a:ext>
             </a:extLst>
           </p:cNvPr>
@@ -3266,7 +3266,7 @@
                           <a:ea typeface="Aptos"/>
                           <a:cs typeface="Aptos"/>
                         </a:rPr>
-                        <a:t>Use 0–10 mm, test budget, guessed width, and confirmed increment</a:t>
+                        <a:t>Use 0–10 mm, a provisional 0.05 mm usable step, and 0.015 mm foil thickness</a:t>
                       </a:r>
                     </a:p>
                   </a:txBody>
@@ -3428,7 +3428,7 @@
           <p:cNvPr id="5" name="">
             <a:extLst xmlns:a="http://schemas.openxmlformats.org/drawingml/2006/main">
               <a:ext uri="{FF2B5EF4-FFF2-40B4-BE49-F238E27FC236}">
-                <a16:creationId xmlns:a16="http://schemas.microsoft.com/office/drawing/2014/main" id="{1B18407A-3BB6-479C-BF04-B230FC1DFA14}"/>
+                <a16:creationId xmlns:a16="http://schemas.microsoft.com/office/drawing/2014/main" id="{596FB1E0-C093-4C68-8744-7E159FBA79F6}"/>
               </a:ext>
             </a:extLst>
           </p:cNvPr>
@@ -3483,7 +3483,7 @@
     </p:spTree>
     <p:extLst>
       <p:ext uri="{BB962C8B-B14F-4D97-AF65-F5344CB8AC3E}">
-        <p14:creationId xmlns:p14="http://schemas.microsoft.com/office/powerpoint/2010/main" val="616640112"/>
+        <p14:creationId xmlns:p14="http://schemas.microsoft.com/office/powerpoint/2010/main" val="1602006648"/>
       </p:ext>
     </p:extLst>
   </p:cSld>
@@ -3514,7 +3514,7 @@
           <p:cNvPr id="9" name="">
             <a:extLst xmlns:a="http://schemas.openxmlformats.org/drawingml/2006/main">
               <a:ext uri="{FF2B5EF4-FFF2-40B4-BE49-F238E27FC236}">
-                <a16:creationId xmlns:a16="http://schemas.microsoft.com/office/drawing/2014/main" id="{F2C8CBB7-278B-4F7B-88AA-D6C5C3EBABA8}"/>
+                <a16:creationId xmlns:a16="http://schemas.microsoft.com/office/drawing/2014/main" id="{264E92D9-0383-487A-9DD9-2D713CBC18B2}"/>
               </a:ext>
             </a:extLst>
           </p:cNvPr>
@@ -3571,7 +3571,7 @@
           <p:cNvPr id="2" name="">
             <a:extLst xmlns:a="http://schemas.openxmlformats.org/drawingml/2006/main">
               <a:ext uri="{FF2B5EF4-FFF2-40B4-BE49-F238E27FC236}">
-                <a16:creationId xmlns:a16="http://schemas.microsoft.com/office/drawing/2014/main" id="{91AFFB1D-78DA-4FD4-A060-2506C184CECF}"/>
+                <a16:creationId xmlns:a16="http://schemas.microsoft.com/office/drawing/2014/main" id="{4073479B-0AF0-496C-8178-06F790CC1985}"/>
               </a:ext>
             </a:extLst>
           </p:cNvPr>
@@ -3601,7 +3601,7 @@
           <p:cNvPr id="3" name="">
             <a:extLst xmlns:a="http://schemas.openxmlformats.org/drawingml/2006/main">
               <a:ext uri="{FF2B5EF4-FFF2-40B4-BE49-F238E27FC236}">
-                <a16:creationId xmlns:a16="http://schemas.microsoft.com/office/drawing/2014/main" id="{C9AFE90E-CD30-4006-A688-C57D7F6AF64B}"/>
+                <a16:creationId xmlns:a16="http://schemas.microsoft.com/office/drawing/2014/main" id="{54F09A98-75E4-4001-BD85-068993695CD6}"/>
               </a:ext>
             </a:extLst>
           </p:cNvPr>
@@ -3658,7 +3658,7 @@
           <p:cNvPr id="4" name="">
             <a:extLst xmlns:a="http://schemas.openxmlformats.org/drawingml/2006/main">
               <a:ext uri="{FF2B5EF4-FFF2-40B4-BE49-F238E27FC236}">
-                <a16:creationId xmlns:a16="http://schemas.microsoft.com/office/drawing/2014/main" id="{1EF82B49-508F-4584-90E9-3619CBD0BA1C}"/>
+                <a16:creationId xmlns:a16="http://schemas.microsoft.com/office/drawing/2014/main" id="{0458B123-2183-4F33-91D3-BBF395194E10}"/>
               </a:ext>
             </a:extLst>
           </p:cNvPr>
@@ -3858,7 +3858,7 @@
                           <a:ea typeface="Aptos"/>
                           <a:cs typeface="Aptos"/>
                         </a:rPr>
-                        <a:t>Every requested, reachable, measured, and outcome value</a:t>
+                        <a:t>Internal target, build request, every reading, measured mean, warning, and outcome</a:t>
                       </a:r>
                     </a:p>
                   </a:txBody>
@@ -3948,7 +3948,7 @@
           <p:cNvPr id="6" name="">
             <a:extLst xmlns:a="http://schemas.openxmlformats.org/drawingml/2006/main">
               <a:ext uri="{FF2B5EF4-FFF2-40B4-BE49-F238E27FC236}">
-                <a16:creationId xmlns:a16="http://schemas.microsoft.com/office/drawing/2014/main" id="{1B689F05-313C-4BEC-9917-4A952A5B8DF7}"/>
+                <a16:creationId xmlns:a16="http://schemas.microsoft.com/office/drawing/2014/main" id="{A1110003-C5F2-499E-B46F-6024D1D7D467}"/>
               </a:ext>
             </a:extLst>
           </p:cNvPr>
@@ -4005,7 +4005,7 @@
           <p:cNvPr id="7" name="">
             <a:extLst xmlns:a="http://schemas.openxmlformats.org/drawingml/2006/main">
               <a:ext uri="{FF2B5EF4-FFF2-40B4-BE49-F238E27FC236}">
-                <a16:creationId xmlns:a16="http://schemas.microsoft.com/office/drawing/2014/main" id="{69713847-43BA-40E0-949F-30326247E555}"/>
+                <a16:creationId xmlns:a16="http://schemas.microsoft.com/office/drawing/2014/main" id="{CDC24D21-2B81-4CA8-95B8-FA9A886C528E}"/>
               </a:ext>
             </a:extLst>
           </p:cNvPr>
@@ -4062,7 +4062,7 @@
           <p:cNvPr id="8" name="">
             <a:extLst xmlns:a="http://schemas.openxmlformats.org/drawingml/2006/main">
               <a:ext uri="{FF2B5EF4-FFF2-40B4-BE49-F238E27FC236}">
-                <a16:creationId xmlns:a16="http://schemas.microsoft.com/office/drawing/2014/main" id="{5E899736-6E2D-4B6C-BCF9-6666235FAFDC}"/>
+                <a16:creationId xmlns:a16="http://schemas.microsoft.com/office/drawing/2014/main" id="{6DCD613D-553B-4ECC-B402-D6FD4A9C87FD}"/>
               </a:ext>
             </a:extLst>
           </p:cNvPr>
@@ -4117,7 +4117,7 @@
     </p:spTree>
     <p:extLst>
       <p:ext uri="{BB962C8B-B14F-4D97-AF65-F5344CB8AC3E}">
-        <p14:creationId xmlns:p14="http://schemas.microsoft.com/office/powerpoint/2010/main" val="350994795"/>
+        <p14:creationId xmlns:p14="http://schemas.microsoft.com/office/powerpoint/2010/main" val="1665724055"/>
       </p:ext>
     </p:extLst>
   </p:cSld>
@@ -4148,7 +4148,7 @@
           <p:cNvPr id="15" name="">
             <a:extLst xmlns:a="http://schemas.openxmlformats.org/drawingml/2006/main">
               <a:ext uri="{FF2B5EF4-FFF2-40B4-BE49-F238E27FC236}">
-                <a16:creationId xmlns:a16="http://schemas.microsoft.com/office/drawing/2014/main" id="{ED432F1B-4841-410A-815E-8AEF367CF655}"/>
+                <a16:creationId xmlns:a16="http://schemas.microsoft.com/office/drawing/2014/main" id="{E2F6995F-54D8-4AEA-A59E-3E24337B452D}"/>
               </a:ext>
             </a:extLst>
           </p:cNvPr>
@@ -4205,7 +4205,7 @@
           <p:cNvPr id="2" name="">
             <a:extLst xmlns:a="http://schemas.openxmlformats.org/drawingml/2006/main">
               <a:ext uri="{FF2B5EF4-FFF2-40B4-BE49-F238E27FC236}">
-                <a16:creationId xmlns:a16="http://schemas.microsoft.com/office/drawing/2014/main" id="{B24EA479-62E9-4D17-BF42-38B44B3F03E4}"/>
+                <a16:creationId xmlns:a16="http://schemas.microsoft.com/office/drawing/2014/main" id="{3C308D19-F66F-4FBA-B429-A91F4F7A7BC9}"/>
               </a:ext>
             </a:extLst>
           </p:cNvPr>
@@ -4235,7 +4235,7 @@
           <p:cNvPr id="3" name="">
             <a:extLst xmlns:a="http://schemas.openxmlformats.org/drawingml/2006/main">
               <a:ext uri="{FF2B5EF4-FFF2-40B4-BE49-F238E27FC236}">
-                <a16:creationId xmlns:a16="http://schemas.microsoft.com/office/drawing/2014/main" id="{33D8078E-2AD1-4957-8FF6-91AC05EF14CB}"/>
+                <a16:creationId xmlns:a16="http://schemas.microsoft.com/office/drawing/2014/main" id="{33F7C1FB-42F5-4B6B-82E3-9F7D7E014404}"/>
               </a:ext>
             </a:extLst>
           </p:cNvPr>
@@ -4282,7 +4282,7 @@
                 <a:ea typeface="Aptos"/>
                 <a:cs typeface="Aptos"/>
               </a:rPr>
-              <a:t>95 / 95</a:t>
+              <a:t>104 / 104</a:t>
             </a:r>
           </a:p>
         </p:txBody>
@@ -4292,7 +4292,7 @@
           <p:cNvPr id="4" name="">
             <a:extLst xmlns:a="http://schemas.openxmlformats.org/drawingml/2006/main">
               <a:ext uri="{FF2B5EF4-FFF2-40B4-BE49-F238E27FC236}">
-                <a16:creationId xmlns:a16="http://schemas.microsoft.com/office/drawing/2014/main" id="{CFD5D869-6E76-49CF-A808-441FAD32B373}"/>
+                <a16:creationId xmlns:a16="http://schemas.microsoft.com/office/drawing/2014/main" id="{176B7365-6CE5-4150-B159-4B76D3D5C35A}"/>
               </a:ext>
             </a:extLst>
           </p:cNvPr>
@@ -4349,7 +4349,7 @@
           <p:cNvPr id="5" name="">
             <a:extLst xmlns:a="http://schemas.openxmlformats.org/drawingml/2006/main">
               <a:ext uri="{FF2B5EF4-FFF2-40B4-BE49-F238E27FC236}">
-                <a16:creationId xmlns:a16="http://schemas.microsoft.com/office/drawing/2014/main" id="{F3419435-FF2F-49E7-A1C0-E5E2250A308B}"/>
+                <a16:creationId xmlns:a16="http://schemas.microsoft.com/office/drawing/2014/main" id="{F4C7356F-AB9D-4527-9C8B-8EAC717F54D9}"/>
               </a:ext>
             </a:extLst>
           </p:cNvPr>
@@ -4406,7 +4406,7 @@
           <p:cNvPr id="6" name="">
             <a:extLst xmlns:a="http://schemas.openxmlformats.org/drawingml/2006/main">
               <a:ext uri="{FF2B5EF4-FFF2-40B4-BE49-F238E27FC236}">
-                <a16:creationId xmlns:a16="http://schemas.microsoft.com/office/drawing/2014/main" id="{2D6573CF-D307-4B04-A518-58072E75DAFE}"/>
+                <a16:creationId xmlns:a16="http://schemas.microsoft.com/office/drawing/2014/main" id="{6984D5B5-8122-4DCB-A04E-84CAFB53E4A5}"/>
               </a:ext>
             </a:extLst>
           </p:cNvPr>
@@ -4463,7 +4463,7 @@
           <p:cNvPr id="7" name="">
             <a:extLst xmlns:a="http://schemas.openxmlformats.org/drawingml/2006/main">
               <a:ext uri="{FF2B5EF4-FFF2-40B4-BE49-F238E27FC236}">
-                <a16:creationId xmlns:a16="http://schemas.microsoft.com/office/drawing/2014/main" id="{BE3DD806-D179-4BAC-A464-527B27D5FD13}"/>
+                <a16:creationId xmlns:a16="http://schemas.microsoft.com/office/drawing/2014/main" id="{72AA287B-26B2-427A-A057-11F9EF311215}"/>
               </a:ext>
             </a:extLst>
           </p:cNvPr>
@@ -4520,7 +4520,7 @@
           <p:cNvPr id="8" name="">
             <a:extLst xmlns:a="http://schemas.openxmlformats.org/drawingml/2006/main">
               <a:ext uri="{FF2B5EF4-FFF2-40B4-BE49-F238E27FC236}">
-                <a16:creationId xmlns:a16="http://schemas.microsoft.com/office/drawing/2014/main" id="{75F156CF-8D14-4C95-A655-7A756DB14BF4}"/>
+                <a16:creationId xmlns:a16="http://schemas.microsoft.com/office/drawing/2014/main" id="{A1278B06-4A77-4CE8-A841-9DACA9C9E016}"/>
               </a:ext>
             </a:extLst>
           </p:cNvPr>
@@ -4577,7 +4577,7 @@
           <p:cNvPr id="9" name="">
             <a:extLst xmlns:a="http://schemas.openxmlformats.org/drawingml/2006/main">
               <a:ext uri="{FF2B5EF4-FFF2-40B4-BE49-F238E27FC236}">
-                <a16:creationId xmlns:a16="http://schemas.microsoft.com/office/drawing/2014/main" id="{CAAE7368-2709-4FB9-A89A-7272DDA18AE0}"/>
+                <a16:creationId xmlns:a16="http://schemas.microsoft.com/office/drawing/2014/main" id="{4ACF9D57-1214-4470-ADD2-C85D608A6D34}"/>
               </a:ext>
             </a:extLst>
           </p:cNvPr>
@@ -4634,7 +4634,7 @@
           <p:cNvPr id="10" name="">
             <a:extLst xmlns:a="http://schemas.openxmlformats.org/drawingml/2006/main">
               <a:ext uri="{FF2B5EF4-FFF2-40B4-BE49-F238E27FC236}">
-                <a16:creationId xmlns:a16="http://schemas.microsoft.com/office/drawing/2014/main" id="{49E800E1-44CE-444C-B393-CDBAD0D895D1}"/>
+                <a16:creationId xmlns:a16="http://schemas.microsoft.com/office/drawing/2014/main" id="{D511240A-655B-4782-AE23-9EA044FA274E}"/>
               </a:ext>
             </a:extLst>
           </p:cNvPr>
@@ -4691,7 +4691,7 @@
           <p:cNvPr id="11" name="">
             <a:extLst xmlns:a="http://schemas.openxmlformats.org/drawingml/2006/main">
               <a:ext uri="{FF2B5EF4-FFF2-40B4-BE49-F238E27FC236}">
-                <a16:creationId xmlns:a16="http://schemas.microsoft.com/office/drawing/2014/main" id="{A5027EBC-FE20-4A3D-8B85-1C98B057E163}"/>
+                <a16:creationId xmlns:a16="http://schemas.microsoft.com/office/drawing/2014/main" id="{D290FFC0-1A77-49E2-AA18-65690393BE99}"/>
               </a:ext>
             </a:extLst>
           </p:cNvPr>
@@ -4721,7 +4721,7 @@
           <p:cNvPr id="12" name="">
             <a:extLst xmlns:a="http://schemas.openxmlformats.org/drawingml/2006/main">
               <a:ext uri="{FF2B5EF4-FFF2-40B4-BE49-F238E27FC236}">
-                <a16:creationId xmlns:a16="http://schemas.microsoft.com/office/drawing/2014/main" id="{EA791447-AC9D-48F9-A924-146DA93EF70E}"/>
+                <a16:creationId xmlns:a16="http://schemas.microsoft.com/office/drawing/2014/main" id="{D8478A6D-2707-47E9-AE2C-25F74FCB81F3}"/>
               </a:ext>
             </a:extLst>
           </p:cNvPr>
@@ -4778,7 +4778,7 @@
           <p:cNvPr id="13" name="">
             <a:extLst xmlns:a="http://schemas.openxmlformats.org/drawingml/2006/main">
               <a:ext uri="{FF2B5EF4-FFF2-40B4-BE49-F238E27FC236}">
-                <a16:creationId xmlns:a16="http://schemas.microsoft.com/office/drawing/2014/main" id="{E1AB7630-35F0-464A-9825-9FA2D6A20A00}"/>
+                <a16:creationId xmlns:a16="http://schemas.microsoft.com/office/drawing/2014/main" id="{0A33383F-BDFA-492C-B205-5E5A9B34C674}"/>
               </a:ext>
             </a:extLst>
           </p:cNvPr>
@@ -4835,7 +4835,7 @@
           <p:cNvPr id="14" name="">
             <a:extLst xmlns:a="http://schemas.openxmlformats.org/drawingml/2006/main">
               <a:ext uri="{FF2B5EF4-FFF2-40B4-BE49-F238E27FC236}">
-                <a16:creationId xmlns:a16="http://schemas.microsoft.com/office/drawing/2014/main" id="{2A24FF55-39D9-4DFC-B95D-16B293169DE5}"/>
+                <a16:creationId xmlns:a16="http://schemas.microsoft.com/office/drawing/2014/main" id="{309135C4-5CB1-4E58-AF6C-33462CAD6378}"/>
               </a:ext>
             </a:extLst>
           </p:cNvPr>
@@ -4882,7 +4882,7 @@
                 <a:ea typeface="Aptos"/>
                 <a:cs typeface="Aptos"/>
               </a:rPr>
-              <a:t>Operator decision still required: confirm whether the real increment is 0.05 mm or 0.10 mm.</a:t>
+              <a:t>Physical confirmation still required: prove whether the provisional 0.05 mm usable resolution is repeatable on complete builds.</a:t>
             </a:r>
           </a:p>
         </p:txBody>
@@ -4890,7 +4890,7 @@
     </p:spTree>
     <p:extLst>
       <p:ext uri="{BB962C8B-B14F-4D97-AF65-F5344CB8AC3E}">
-        <p14:creationId xmlns:p14="http://schemas.microsoft.com/office/powerpoint/2010/main" val="951181584"/>
+        <p14:creationId xmlns:p14="http://schemas.microsoft.com/office/powerpoint/2010/main" val="1012774656"/>
       </p:ext>
     </p:extLst>
   </p:cSld>
@@ -4921,7 +4921,7 @@
           <p:cNvPr id="17" name="">
             <a:extLst xmlns:a="http://schemas.openxmlformats.org/drawingml/2006/main">
               <a:ext uri="{FF2B5EF4-FFF2-40B4-BE49-F238E27FC236}">
-                <a16:creationId xmlns:a16="http://schemas.microsoft.com/office/drawing/2014/main" id="{9FA5D61D-84C8-4A3C-A46E-B031EC8B6503}"/>
+                <a16:creationId xmlns:a16="http://schemas.microsoft.com/office/drawing/2014/main" id="{E6785FAD-D6EC-4C84-9224-AC2C1DF0367E}"/>
               </a:ext>
             </a:extLst>
           </p:cNvPr>
@@ -4978,7 +4978,7 @@
           <p:cNvPr id="2" name="">
             <a:extLst xmlns:a="http://schemas.openxmlformats.org/drawingml/2006/main">
               <a:ext uri="{FF2B5EF4-FFF2-40B4-BE49-F238E27FC236}">
-                <a16:creationId xmlns:a16="http://schemas.microsoft.com/office/drawing/2014/main" id="{3F00CC91-7BE7-47A9-8B94-5992A2C131B0}"/>
+                <a16:creationId xmlns:a16="http://schemas.microsoft.com/office/drawing/2014/main" id="{73C5D064-862B-4D89-AF44-59D1BB796D71}"/>
               </a:ext>
             </a:extLst>
           </p:cNvPr>
@@ -5008,7 +5008,7 @@
           <p:cNvPr id="3" name="">
             <a:extLst xmlns:a="http://schemas.openxmlformats.org/drawingml/2006/main">
               <a:ext uri="{FF2B5EF4-FFF2-40B4-BE49-F238E27FC236}">
-                <a16:creationId xmlns:a16="http://schemas.microsoft.com/office/drawing/2014/main" id="{0BADEFD6-3DB2-44BE-8CF0-3BD53B0E63DE}"/>
+                <a16:creationId xmlns:a16="http://schemas.microsoft.com/office/drawing/2014/main" id="{199FF9F0-F64B-4D31-A976-EA24ED0C938C}"/>
               </a:ext>
             </a:extLst>
           </p:cNvPr>
@@ -5069,7 +5069,7 @@
           <p:nvPr/>
         </p:nvPicPr>
         <p:blipFill>
-          <a:blip xmlns:r="http://schemas.openxmlformats.org/officeDocument/2006/relationships" xmlns:a="http://schemas.openxmlformats.org/drawingml/2006/main" r:embed="Rf43a7590ae8a4808"/>
+          <a:blip xmlns:r="http://schemas.openxmlformats.org/officeDocument/2006/relationships" xmlns:a="http://schemas.openxmlformats.org/drawingml/2006/main" r:embed="R5c26398be1b6448e"/>
           <a:stretch xmlns:a="http://schemas.openxmlformats.org/drawingml/2006/main"/>
         </p:blipFill>
         <p:spPr>
@@ -5087,7 +5087,7 @@
           <p:cNvPr id="5" name="">
             <a:extLst xmlns:a="http://schemas.openxmlformats.org/drawingml/2006/main">
               <a:ext uri="{FF2B5EF4-FFF2-40B4-BE49-F238E27FC236}">
-                <a16:creationId xmlns:a16="http://schemas.microsoft.com/office/drawing/2014/main" id="{FBCB84F5-6F5F-4125-BD75-FD093978369A}"/>
+                <a16:creationId xmlns:a16="http://schemas.microsoft.com/office/drawing/2014/main" id="{AF5AE90B-07F2-491E-BF84-4F0BF6D7EE7A}"/>
               </a:ext>
             </a:extLst>
           </p:cNvPr>
@@ -5144,7 +5144,7 @@
           <p:cNvPr id="6" name="">
             <a:extLst xmlns:a="http://schemas.openxmlformats.org/drawingml/2006/main">
               <a:ext uri="{FF2B5EF4-FFF2-40B4-BE49-F238E27FC236}">
-                <a16:creationId xmlns:a16="http://schemas.microsoft.com/office/drawing/2014/main" id="{6C28D8E0-6386-4B43-9230-79C340EF21DA}"/>
+                <a16:creationId xmlns:a16="http://schemas.microsoft.com/office/drawing/2014/main" id="{FC4A5AB7-E634-4C17-9114-2DAE3D41F2E2}"/>
               </a:ext>
             </a:extLst>
           </p:cNvPr>
@@ -5201,7 +5201,7 @@
           <p:cNvPr id="7" name="">
             <a:extLst xmlns:a="http://schemas.openxmlformats.org/drawingml/2006/main">
               <a:ext uri="{FF2B5EF4-FFF2-40B4-BE49-F238E27FC236}">
-                <a16:creationId xmlns:a16="http://schemas.microsoft.com/office/drawing/2014/main" id="{7E7402F1-71BF-4721-B0B7-FE00358E2F6F}"/>
+                <a16:creationId xmlns:a16="http://schemas.microsoft.com/office/drawing/2014/main" id="{3A4E30EB-D624-444D-B1E6-1F9BA1DFE450}"/>
               </a:ext>
             </a:extLst>
           </p:cNvPr>
@@ -5258,7 +5258,7 @@
           <p:cNvPr id="8" name="">
             <a:extLst xmlns:a="http://schemas.openxmlformats.org/drawingml/2006/main">
               <a:ext uri="{FF2B5EF4-FFF2-40B4-BE49-F238E27FC236}">
-                <a16:creationId xmlns:a16="http://schemas.microsoft.com/office/drawing/2014/main" id="{2AD33FAF-7EE9-4D42-9B6B-9D6A21240500}"/>
+                <a16:creationId xmlns:a16="http://schemas.microsoft.com/office/drawing/2014/main" id="{6539FEC0-4703-4F4A-82CD-730607F3D9A7}"/>
               </a:ext>
             </a:extLst>
           </p:cNvPr>
@@ -5315,7 +5315,7 @@
           <p:cNvPr id="9" name="">
             <a:extLst xmlns:a="http://schemas.openxmlformats.org/drawingml/2006/main">
               <a:ext uri="{FF2B5EF4-FFF2-40B4-BE49-F238E27FC236}">
-                <a16:creationId xmlns:a16="http://schemas.microsoft.com/office/drawing/2014/main" id="{8EC79523-A7EB-4529-9E3A-EA6408B718AB}"/>
+                <a16:creationId xmlns:a16="http://schemas.microsoft.com/office/drawing/2014/main" id="{7275C131-F00C-49FE-AADF-9F0980EF38AB}"/>
               </a:ext>
             </a:extLst>
           </p:cNvPr>
@@ -5372,7 +5372,7 @@
           <p:cNvPr id="10" name="">
             <a:extLst xmlns:a="http://schemas.openxmlformats.org/drawingml/2006/main">
               <a:ext uri="{FF2B5EF4-FFF2-40B4-BE49-F238E27FC236}">
-                <a16:creationId xmlns:a16="http://schemas.microsoft.com/office/drawing/2014/main" id="{E7C01C5B-B037-4681-BFB3-6F4BE095C4FE}"/>
+                <a16:creationId xmlns:a16="http://schemas.microsoft.com/office/drawing/2014/main" id="{0D2433FB-6A71-4D36-A946-141CC5F9F275}"/>
               </a:ext>
             </a:extLst>
           </p:cNvPr>
@@ -5429,7 +5429,7 @@
           <p:cNvPr id="11" name="">
             <a:extLst xmlns:a="http://schemas.openxmlformats.org/drawingml/2006/main">
               <a:ext uri="{FF2B5EF4-FFF2-40B4-BE49-F238E27FC236}">
-                <a16:creationId xmlns:a16="http://schemas.microsoft.com/office/drawing/2014/main" id="{A2FE8C65-609D-4FD9-9AE2-C0B01D562DD8}"/>
+                <a16:creationId xmlns:a16="http://schemas.microsoft.com/office/drawing/2014/main" id="{4D4933A4-3FF8-4D33-87A7-7300644B0999}"/>
               </a:ext>
             </a:extLst>
           </p:cNvPr>
@@ -5486,7 +5486,7 @@
           <p:cNvPr id="12" name="">
             <a:extLst xmlns:a="http://schemas.openxmlformats.org/drawingml/2006/main">
               <a:ext uri="{FF2B5EF4-FFF2-40B4-BE49-F238E27FC236}">
-                <a16:creationId xmlns:a16="http://schemas.microsoft.com/office/drawing/2014/main" id="{30764E0D-716E-4E7A-940E-2C720E300732}"/>
+                <a16:creationId xmlns:a16="http://schemas.microsoft.com/office/drawing/2014/main" id="{AA801349-647E-4E5E-AB21-9AB2ADD1DECF}"/>
               </a:ext>
             </a:extLst>
           </p:cNvPr>
@@ -5543,7 +5543,7 @@
           <p:cNvPr id="13" name="">
             <a:extLst xmlns:a="http://schemas.openxmlformats.org/drawingml/2006/main">
               <a:ext uri="{FF2B5EF4-FFF2-40B4-BE49-F238E27FC236}">
-                <a16:creationId xmlns:a16="http://schemas.microsoft.com/office/drawing/2014/main" id="{738BAF9E-2AF6-4B36-9E33-9F1AAB104353}"/>
+                <a16:creationId xmlns:a16="http://schemas.microsoft.com/office/drawing/2014/main" id="{B42C25BB-F0F9-42F4-86E5-5B214FB7E8C9}"/>
               </a:ext>
             </a:extLst>
           </p:cNvPr>
@@ -5573,7 +5573,7 @@
           <p:cNvPr id="14" name="">
             <a:extLst xmlns:a="http://schemas.openxmlformats.org/drawingml/2006/main">
               <a:ext uri="{FF2B5EF4-FFF2-40B4-BE49-F238E27FC236}">
-                <a16:creationId xmlns:a16="http://schemas.microsoft.com/office/drawing/2014/main" id="{D6B0692C-1573-4598-A8E6-F1F3F80B220E}"/>
+                <a16:creationId xmlns:a16="http://schemas.microsoft.com/office/drawing/2014/main" id="{26AEF727-8328-4027-8236-1CF97796EB28}"/>
               </a:ext>
             </a:extLst>
           </p:cNvPr>
@@ -5603,7 +5603,7 @@
           <p:cNvPr id="15" name="">
             <a:extLst xmlns:a="http://schemas.openxmlformats.org/drawingml/2006/main">
               <a:ext uri="{FF2B5EF4-FFF2-40B4-BE49-F238E27FC236}">
-                <a16:creationId xmlns:a16="http://schemas.microsoft.com/office/drawing/2014/main" id="{F4894919-8F44-4AB5-A369-531C81AAA5A3}"/>
+                <a16:creationId xmlns:a16="http://schemas.microsoft.com/office/drawing/2014/main" id="{34EC8994-880F-4915-9D22-2939E7932FA4}"/>
               </a:ext>
             </a:extLst>
           </p:cNvPr>
@@ -5633,7 +5633,7 @@
           <p:cNvPr id="16" name="">
             <a:extLst xmlns:a="http://schemas.openxmlformats.org/drawingml/2006/main">
               <a:ext uri="{FF2B5EF4-FFF2-40B4-BE49-F238E27FC236}">
-                <a16:creationId xmlns:a16="http://schemas.microsoft.com/office/drawing/2014/main" id="{42755349-E32B-41CC-A8E3-9178EC139A2E}"/>
+                <a16:creationId xmlns:a16="http://schemas.microsoft.com/office/drawing/2014/main" id="{E28EFF4A-4F6E-4E04-AF49-01B27AC1396A}"/>
               </a:ext>
             </a:extLst>
           </p:cNvPr>
@@ -5688,7 +5688,7 @@
     </p:spTree>
     <p:extLst>
       <p:ext uri="{BB962C8B-B14F-4D97-AF65-F5344CB8AC3E}">
-        <p14:creationId xmlns:p14="http://schemas.microsoft.com/office/powerpoint/2010/main" val="1519160331"/>
+        <p14:creationId xmlns:p14="http://schemas.microsoft.com/office/powerpoint/2010/main" val="1993962561"/>
       </p:ext>
     </p:extLst>
   </p:cSld>
@@ -5719,7 +5719,7 @@
           <p:cNvPr id="6" name="">
             <a:extLst xmlns:a="http://schemas.openxmlformats.org/drawingml/2006/main">
               <a:ext uri="{FF2B5EF4-FFF2-40B4-BE49-F238E27FC236}">
-                <a16:creationId xmlns:a16="http://schemas.microsoft.com/office/drawing/2014/main" id="{74CB18F5-5B2A-4377-9679-33CC64D24482}"/>
+                <a16:creationId xmlns:a16="http://schemas.microsoft.com/office/drawing/2014/main" id="{9B92F785-6D07-4683-8B2D-58063D58B832}"/>
               </a:ext>
             </a:extLst>
           </p:cNvPr>
@@ -5776,7 +5776,7 @@
           <p:cNvPr id="2" name="">
             <a:extLst xmlns:a="http://schemas.openxmlformats.org/drawingml/2006/main">
               <a:ext uri="{FF2B5EF4-FFF2-40B4-BE49-F238E27FC236}">
-                <a16:creationId xmlns:a16="http://schemas.microsoft.com/office/drawing/2014/main" id="{50A679EA-E29F-49A8-8F1D-668F16BC7AF0}"/>
+                <a16:creationId xmlns:a16="http://schemas.microsoft.com/office/drawing/2014/main" id="{A9C956BF-7266-45BA-873D-EAF22ACF73F8}"/>
               </a:ext>
             </a:extLst>
           </p:cNvPr>
@@ -5806,7 +5806,7 @@
           <p:cNvPr id="3" name="">
             <a:extLst xmlns:a="http://schemas.openxmlformats.org/drawingml/2006/main">
               <a:ext uri="{FF2B5EF4-FFF2-40B4-BE49-F238E27FC236}">
-                <a16:creationId xmlns:a16="http://schemas.microsoft.com/office/drawing/2014/main" id="{AE681BFE-EE9A-4780-842D-CF8B77BD6EE5}"/>
+                <a16:creationId xmlns:a16="http://schemas.microsoft.com/office/drawing/2014/main" id="{B5EEA544-70FD-498C-9115-CD68C228F198}"/>
               </a:ext>
             </a:extLst>
           </p:cNvPr>
@@ -6430,7 +6430,7 @@
           <p:cNvPr id="5" name="">
             <a:extLst xmlns:a="http://schemas.openxmlformats.org/drawingml/2006/main">
               <a:ext uri="{FF2B5EF4-FFF2-40B4-BE49-F238E27FC236}">
-                <a16:creationId xmlns:a16="http://schemas.microsoft.com/office/drawing/2014/main" id="{FCDC18A5-3806-4EBF-9DB0-6E624F24F043}"/>
+                <a16:creationId xmlns:a16="http://schemas.microsoft.com/office/drawing/2014/main" id="{22A86097-449A-4F4C-9810-FF8153C8BD69}"/>
               </a:ext>
             </a:extLst>
           </p:cNvPr>
@@ -6485,7 +6485,7 @@
     </p:spTree>
     <p:extLst>
       <p:ext uri="{BB962C8B-B14F-4D97-AF65-F5344CB8AC3E}">
-        <p14:creationId xmlns:p14="http://schemas.microsoft.com/office/powerpoint/2010/main" val="1383853570"/>
+        <p14:creationId xmlns:p14="http://schemas.microsoft.com/office/powerpoint/2010/main" val="774516429"/>
       </p:ext>
     </p:extLst>
   </p:cSld>
@@ -6516,7 +6516,7 @@
           <p:cNvPr id="11" name="">
             <a:extLst xmlns:a="http://schemas.openxmlformats.org/drawingml/2006/main">
               <a:ext uri="{FF2B5EF4-FFF2-40B4-BE49-F238E27FC236}">
-                <a16:creationId xmlns:a16="http://schemas.microsoft.com/office/drawing/2014/main" id="{43F08359-8069-4B57-94B7-AB16E7B4DB80}"/>
+                <a16:creationId xmlns:a16="http://schemas.microsoft.com/office/drawing/2014/main" id="{89CC8D47-853D-4154-852E-B86204929E9B}"/>
               </a:ext>
             </a:extLst>
           </p:cNvPr>
@@ -6573,7 +6573,7 @@
           <p:cNvPr id="2" name="">
             <a:extLst xmlns:a="http://schemas.openxmlformats.org/drawingml/2006/main">
               <a:ext uri="{FF2B5EF4-FFF2-40B4-BE49-F238E27FC236}">
-                <a16:creationId xmlns:a16="http://schemas.microsoft.com/office/drawing/2014/main" id="{220D6A54-F4F9-4E69-8582-4420C4D4712B}"/>
+                <a16:creationId xmlns:a16="http://schemas.microsoft.com/office/drawing/2014/main" id="{5A48C272-7CD5-445B-879C-DB8DC59F6A1C}"/>
               </a:ext>
             </a:extLst>
           </p:cNvPr>
@@ -6603,7 +6603,7 @@
           <p:cNvPr id="3" name="">
             <a:extLst xmlns:a="http://schemas.openxmlformats.org/drawingml/2006/main">
               <a:ext uri="{FF2B5EF4-FFF2-40B4-BE49-F238E27FC236}">
-                <a16:creationId xmlns:a16="http://schemas.microsoft.com/office/drawing/2014/main" id="{69A560DD-1989-415E-A67B-B640C50C249C}"/>
+                <a16:creationId xmlns:a16="http://schemas.microsoft.com/office/drawing/2014/main" id="{1589AC52-6BB1-4293-9787-071221327D98}"/>
               </a:ext>
             </a:extLst>
           </p:cNvPr>
@@ -6660,7 +6660,7 @@
           <p:cNvPr id="4" name="">
             <a:extLst xmlns:a="http://schemas.openxmlformats.org/drawingml/2006/main">
               <a:ext uri="{FF2B5EF4-FFF2-40B4-BE49-F238E27FC236}">
-                <a16:creationId xmlns:a16="http://schemas.microsoft.com/office/drawing/2014/main" id="{E0E28B2D-976B-4FA6-9AB6-D9331742528B}"/>
+                <a16:creationId xmlns:a16="http://schemas.microsoft.com/office/drawing/2014/main" id="{52168784-E6BE-4185-9197-C3CF27BAA892}"/>
               </a:ext>
             </a:extLst>
           </p:cNvPr>
@@ -6717,7 +6717,7 @@
           <p:cNvPr id="5" name="">
             <a:extLst xmlns:a="http://schemas.openxmlformats.org/drawingml/2006/main">
               <a:ext uri="{FF2B5EF4-FFF2-40B4-BE49-F238E27FC236}">
-                <a16:creationId xmlns:a16="http://schemas.microsoft.com/office/drawing/2014/main" id="{4C18FD7D-5354-49C2-A4AD-9BDCC83F3854}"/>
+                <a16:creationId xmlns:a16="http://schemas.microsoft.com/office/drawing/2014/main" id="{83DABEB5-E3BD-458B-A858-414C5D36EDDA}"/>
               </a:ext>
             </a:extLst>
           </p:cNvPr>
@@ -6774,7 +6774,7 @@
           <p:cNvPr id="6" name="">
             <a:extLst xmlns:a="http://schemas.openxmlformats.org/drawingml/2006/main">
               <a:ext uri="{FF2B5EF4-FFF2-40B4-BE49-F238E27FC236}">
-                <a16:creationId xmlns:a16="http://schemas.microsoft.com/office/drawing/2014/main" id="{B0C0339D-657B-48D6-83C4-5EE5BA48D8F4}"/>
+                <a16:creationId xmlns:a16="http://schemas.microsoft.com/office/drawing/2014/main" id="{7CB443DE-2901-4670-9B14-006D517F3F14}"/>
               </a:ext>
             </a:extLst>
           </p:cNvPr>
@@ -6831,7 +6831,7 @@
           <p:cNvPr id="7" name="">
             <a:extLst xmlns:a="http://schemas.openxmlformats.org/drawingml/2006/main">
               <a:ext uri="{FF2B5EF4-FFF2-40B4-BE49-F238E27FC236}">
-                <a16:creationId xmlns:a16="http://schemas.microsoft.com/office/drawing/2014/main" id="{2E1BFE14-10A5-4527-87B3-5D69EAFF79CF}"/>
+                <a16:creationId xmlns:a16="http://schemas.microsoft.com/office/drawing/2014/main" id="{A3FB4F22-0CDE-490B-97CB-9D0124C67128}"/>
               </a:ext>
             </a:extLst>
           </p:cNvPr>
@@ -7183,7 +7183,7 @@
           <p:cNvPr id="9" name="">
             <a:extLst xmlns:a="http://schemas.openxmlformats.org/drawingml/2006/main">
               <a:ext uri="{FF2B5EF4-FFF2-40B4-BE49-F238E27FC236}">
-                <a16:creationId xmlns:a16="http://schemas.microsoft.com/office/drawing/2014/main" id="{45AF8A72-F5C1-41D8-90B7-569B39416363}"/>
+                <a16:creationId xmlns:a16="http://schemas.microsoft.com/office/drawing/2014/main" id="{E93F8724-AAA3-490D-9169-AEDEA458F003}"/>
               </a:ext>
             </a:extLst>
           </p:cNvPr>
@@ -7240,7 +7240,7 @@
           <p:cNvPr id="10" name="">
             <a:extLst xmlns:a="http://schemas.openxmlformats.org/drawingml/2006/main">
               <a:ext uri="{FF2B5EF4-FFF2-40B4-BE49-F238E27FC236}">
-                <a16:creationId xmlns:a16="http://schemas.microsoft.com/office/drawing/2014/main" id="{5DE60EBC-85ED-4B8C-BCF9-4FF5C4972CA7}"/>
+                <a16:creationId xmlns:a16="http://schemas.microsoft.com/office/drawing/2014/main" id="{B4FF1942-97D0-47B2-A78D-30C4C4B745F7}"/>
               </a:ext>
             </a:extLst>
           </p:cNvPr>
@@ -7295,7 +7295,7 @@
     </p:spTree>
     <p:extLst>
       <p:ext uri="{BB962C8B-B14F-4D97-AF65-F5344CB8AC3E}">
-        <p14:creationId xmlns:p14="http://schemas.microsoft.com/office/powerpoint/2010/main" val="1591916715"/>
+        <p14:creationId xmlns:p14="http://schemas.microsoft.com/office/powerpoint/2010/main" val="718063332"/>
       </p:ext>
     </p:extLst>
   </p:cSld>
@@ -7326,7 +7326,7 @@
           <p:cNvPr id="8" name="">
             <a:extLst xmlns:a="http://schemas.openxmlformats.org/drawingml/2006/main">
               <a:ext uri="{FF2B5EF4-FFF2-40B4-BE49-F238E27FC236}">
-                <a16:creationId xmlns:a16="http://schemas.microsoft.com/office/drawing/2014/main" id="{3B8F31B2-924A-4704-95B1-922311F2D9D2}"/>
+                <a16:creationId xmlns:a16="http://schemas.microsoft.com/office/drawing/2014/main" id="{9B9A4E9C-C8BC-480A-BD26-3B3C6AA61CB6}"/>
               </a:ext>
             </a:extLst>
           </p:cNvPr>
@@ -7383,7 +7383,7 @@
           <p:cNvPr id="2" name="">
             <a:extLst xmlns:a="http://schemas.openxmlformats.org/drawingml/2006/main">
               <a:ext uri="{FF2B5EF4-FFF2-40B4-BE49-F238E27FC236}">
-                <a16:creationId xmlns:a16="http://schemas.microsoft.com/office/drawing/2014/main" id="{EC5F4C7A-2C40-4C87-A5F5-5C8E502318CC}"/>
+                <a16:creationId xmlns:a16="http://schemas.microsoft.com/office/drawing/2014/main" id="{83E938D6-77F0-4360-A54E-2A09D6EBE8E6}"/>
               </a:ext>
             </a:extLst>
           </p:cNvPr>
@@ -7413,7 +7413,7 @@
           <p:cNvPr id="3" name="">
             <a:extLst xmlns:a="http://schemas.openxmlformats.org/drawingml/2006/main">
               <a:ext uri="{FF2B5EF4-FFF2-40B4-BE49-F238E27FC236}">
-                <a16:creationId xmlns:a16="http://schemas.microsoft.com/office/drawing/2014/main" id="{28EE63A0-6294-49C0-8CDE-9424AFE9BE1E}"/>
+                <a16:creationId xmlns:a16="http://schemas.microsoft.com/office/drawing/2014/main" id="{DE3190D2-A9FC-4DC9-8749-BA22AC838FE7}"/>
               </a:ext>
             </a:extLst>
           </p:cNvPr>
@@ -7573,7 +7573,7 @@
                           <a:ea typeface="Aptos"/>
                           <a:cs typeface="Aptos"/>
                         </a:rPr>
-                        <a:t>Requested</a:t>
+                        <a:t>Internal target</a:t>
                       </a:r>
                     </a:p>
                   </a:txBody>
@@ -7613,7 +7613,7 @@
                           <a:ea typeface="Aptos"/>
                           <a:cs typeface="Aptos"/>
                         </a:rPr>
-                        <a:t>Kept in the audit record</a:t>
+                        <a:t>Saved at full precision</a:t>
                       </a:r>
                     </a:p>
                   </a:txBody>
@@ -7635,7 +7635,7 @@
                           <a:ea typeface="Aptos"/>
                           <a:cs typeface="Aptos"/>
                         </a:rPr>
-                        <a:t>Reachable</a:t>
+                        <a:t>Build request</a:t>
                       </a:r>
                     </a:p>
                   </a:txBody>
@@ -7659,7 +7659,7 @@
                           <a:ea typeface="Aptos"/>
                           <a:cs typeface="Aptos"/>
                         </a:rPr>
-                        <a:t>Nearest different buildable and useful setting</a:t>
+                        <a:t>Useful physical setting</a:t>
                       </a:r>
                     </a:p>
                   </a:txBody>
@@ -7683,7 +7683,7 @@
                           <a:ea typeface="Aptos"/>
                           <a:cs typeface="Aptos"/>
                         </a:rPr>
-                        <a:t>Shown to the operator</a:t>
+                        <a:t>Shown with exactly two decimals</a:t>
                       </a:r>
                     </a:p>
                   </a:txBody>
@@ -7765,7 +7765,7 @@
           <p:cNvPr id="5" name="">
             <a:extLst xmlns:a="http://schemas.openxmlformats.org/drawingml/2006/main">
               <a:ext uri="{FF2B5EF4-FFF2-40B4-BE49-F238E27FC236}">
-                <a16:creationId xmlns:a16="http://schemas.microsoft.com/office/drawing/2014/main" id="{E4BAC0AB-EAE0-4459-B8BC-7817F79E3256}"/>
+                <a16:creationId xmlns:a16="http://schemas.microsoft.com/office/drawing/2014/main" id="{80F54BE0-6E58-404A-A9E5-A6221D97A2AA}"/>
               </a:ext>
             </a:extLst>
           </p:cNvPr>
@@ -7777,7 +7777,7 @@
         <p:spPr>
           <a:xfrm xmlns:a="http://schemas.openxmlformats.org/drawingml/2006/main">
             <a:off x="609600" y="4362450"/>
-            <a:ext cx="6477000" cy="381000"/>
+            <a:ext cx="7810500" cy="381000"/>
           </a:xfrm>
           <a:prstGeom xmlns:a="http://schemas.openxmlformats.org/drawingml/2006/main" prst="rect">
             <a:avLst/>
@@ -7812,7 +7812,7 @@
                 <a:ea typeface="Aptos"/>
                 <a:cs typeface="Aptos"/>
               </a:rPr>
-              <a:t>Each destructive test uses a new spacer build</a:t>
+              <a:t>Physical control and material thickness stay separate</a:t>
             </a:r>
           </a:p>
         </p:txBody>
@@ -7822,7 +7822,7 @@
           <p:cNvPr id="6" name="">
             <a:extLst xmlns:a="http://schemas.openxmlformats.org/drawingml/2006/main">
               <a:ext uri="{FF2B5EF4-FFF2-40B4-BE49-F238E27FC236}">
-                <a16:creationId xmlns:a16="http://schemas.microsoft.com/office/drawing/2014/main" id="{E32C5807-6C87-4DB5-A211-EAEDC8FB4D60}"/>
+                <a16:creationId xmlns:a16="http://schemas.microsoft.com/office/drawing/2014/main" id="{ECA1C3A6-004B-482E-953A-32139119A450}"/>
               </a:ext>
             </a:extLst>
           </p:cNvPr>
@@ -7834,7 +7834,7 @@
         <p:spPr>
           <a:xfrm xmlns:a="http://schemas.openxmlformats.org/drawingml/2006/main">
             <a:off x="609600" y="4876800"/>
-            <a:ext cx="10572750" cy="952500"/>
+            <a:ext cx="10572750" cy="1000125"/>
           </a:xfrm>
           <a:prstGeom xmlns:a="http://schemas.openxmlformats.org/drawingml/2006/main" prst="rect">
             <a:avLst/>
@@ -7851,7 +7851,7 @@
           <a:lstStyle xmlns:a="http://schemas.openxmlformats.org/drawingml/2006/main"/>
           <a:p xmlns:a="http://schemas.openxmlformats.org/drawingml/2006/main">
             <a:pPr algn="l">
-              <a:defRPr sz="1650" b="0">
+              <a:defRPr sz="1575" b="0">
                 <a:solidFill>
                   <a:srgbClr val="142738"/>
                 </a:solidFill>
@@ -7861,7 +7861,7 @@
               </a:defRPr>
             </a:pPr>
             <a:r>
-              <a:rPr sz="1650" b="0">
+              <a:rPr sz="1575" b="0">
                 <a:solidFill>
                   <a:srgbClr val="142738"/>
                 </a:solidFill>
@@ -7869,7 +7869,7 @@
                 <a:ea typeface="Aptos"/>
                 <a:cs typeface="Aptos"/>
               </a:rPr>
-              <a:t>Build the requested reachable setting. Measure the unchanged setup four or five times before testing. Enter all readings, then record Interaction or No interaction. Do not reuse the melted spacer.</a:t>
+              <a:t>Foil is approximately 0.015 mm thick. Printed 0.50 mm spacers have measured about 0.49 to 0.52 mm. V1.9 therefore uses a provisional 0.05 mm usable resolution and a 0.10 mm Stage-2 planning floor. Every final assembly is measured before testing.</a:t>
             </a:r>
           </a:p>
         </p:txBody>
@@ -7879,7 +7879,7 @@
           <p:cNvPr id="7" name="">
             <a:extLst xmlns:a="http://schemas.openxmlformats.org/drawingml/2006/main">
               <a:ext uri="{FF2B5EF4-FFF2-40B4-BE49-F238E27FC236}">
-                <a16:creationId xmlns:a16="http://schemas.microsoft.com/office/drawing/2014/main" id="{179A8097-FC9B-4A91-9521-E6D5CF51F7F2}"/>
+                <a16:creationId xmlns:a16="http://schemas.microsoft.com/office/drawing/2014/main" id="{33DD75D0-45B5-4E2D-8101-D80786281374}"/>
               </a:ext>
             </a:extLst>
           </p:cNvPr>
@@ -7934,7 +7934,7 @@
     </p:spTree>
     <p:extLst>
       <p:ext uri="{BB962C8B-B14F-4D97-AF65-F5344CB8AC3E}">
-        <p14:creationId xmlns:p14="http://schemas.microsoft.com/office/powerpoint/2010/main" val="321471551"/>
+        <p14:creationId xmlns:p14="http://schemas.microsoft.com/office/powerpoint/2010/main" val="1850737108"/>
       </p:ext>
     </p:extLst>
   </p:cSld>
@@ -7965,7 +7965,7 @@
           <p:cNvPr id="8" name="">
             <a:extLst xmlns:a="http://schemas.openxmlformats.org/drawingml/2006/main">
               <a:ext uri="{FF2B5EF4-FFF2-40B4-BE49-F238E27FC236}">
-                <a16:creationId xmlns:a16="http://schemas.microsoft.com/office/drawing/2014/main" id="{1CD2DFF0-7C4E-45CC-A72F-B116364C4C3E}"/>
+                <a16:creationId xmlns:a16="http://schemas.microsoft.com/office/drawing/2014/main" id="{2B189086-F9DD-4F8B-8B12-148B37D34584}"/>
               </a:ext>
             </a:extLst>
           </p:cNvPr>
@@ -8012,7 +8012,7 @@
                 <a:ea typeface="Aptos"/>
                 <a:cs typeface="Aptos"/>
               </a:rPr>
-              <a:t>Equipment resolution changes Stage 2 performance</a:t>
+              <a:t>Usable resolution changes Stage 2 performance</a:t>
             </a:r>
           </a:p>
         </p:txBody>
@@ -8022,7 +8022,7 @@
           <p:cNvPr id="2" name="">
             <a:extLst xmlns:a="http://schemas.openxmlformats.org/drawingml/2006/main">
               <a:ext uri="{FF2B5EF4-FFF2-40B4-BE49-F238E27FC236}">
-                <a16:creationId xmlns:a16="http://schemas.microsoft.com/office/drawing/2014/main" id="{D5DB96B1-EA94-42F4-8661-1621AE96108E}"/>
+                <a16:creationId xmlns:a16="http://schemas.microsoft.com/office/drawing/2014/main" id="{61F135E0-B9B2-40E4-B90D-A46D5D02C6BF}"/>
               </a:ext>
             </a:extLst>
           </p:cNvPr>
@@ -8052,7 +8052,7 @@
           <p:cNvPr id="3" name="">
             <a:extLst xmlns:a="http://schemas.openxmlformats.org/drawingml/2006/main">
               <a:ext uri="{FF2B5EF4-FFF2-40B4-BE49-F238E27FC236}">
-                <a16:creationId xmlns:a16="http://schemas.microsoft.com/office/drawing/2014/main" id="{1B897F9B-114B-40BA-B559-3F445F101C42}"/>
+                <a16:creationId xmlns:a16="http://schemas.microsoft.com/office/drawing/2014/main" id="{1ADFD812-2818-4CB7-B528-9B3C7D3FCD59}"/>
               </a:ext>
             </a:extLst>
           </p:cNvPr>
@@ -8116,7 +8116,7 @@
         </p:xfrm>
         <a:graphic xmlns:a="http://schemas.openxmlformats.org/drawingml/2006/main">
           <a:graphicData uri="http://schemas.openxmlformats.org/drawingml/2006/chart">
-            <c:chart xmlns:r="http://schemas.openxmlformats.org/officeDocument/2006/relationships" xmlns:c="http://schemas.openxmlformats.org/drawingml/2006/chart" r:id="R31e49b6140544487"/>
+            <c:chart xmlns:r="http://schemas.openxmlformats.org/officeDocument/2006/relationships" xmlns:c="http://schemas.openxmlformats.org/drawingml/2006/chart" r:id="R0e111467753d4656"/>
           </a:graphicData>
         </a:graphic>
       </p:graphicFrame>
@@ -8125,7 +8125,7 @@
           <p:cNvPr id="5" name="">
             <a:extLst xmlns:a="http://schemas.openxmlformats.org/drawingml/2006/main">
               <a:ext uri="{FF2B5EF4-FFF2-40B4-BE49-F238E27FC236}">
-                <a16:creationId xmlns:a16="http://schemas.microsoft.com/office/drawing/2014/main" id="{66452DED-027F-44EC-969C-92DDCD586373}"/>
+                <a16:creationId xmlns:a16="http://schemas.microsoft.com/office/drawing/2014/main" id="{5D72C671-D359-4459-BC71-A1D2FB49D08C}"/>
               </a:ext>
             </a:extLst>
           </p:cNvPr>
@@ -8182,7 +8182,7 @@
           <p:cNvPr id="6" name="">
             <a:extLst xmlns:a="http://schemas.openxmlformats.org/drawingml/2006/main">
               <a:ext uri="{FF2B5EF4-FFF2-40B4-BE49-F238E27FC236}">
-                <a16:creationId xmlns:a16="http://schemas.microsoft.com/office/drawing/2014/main" id="{AB34A88B-2E65-401B-9006-C14DA4AD45EF}"/>
+                <a16:creationId xmlns:a16="http://schemas.microsoft.com/office/drawing/2014/main" id="{358C22A4-32D9-44A8-94AC-D74DC440DA94}"/>
               </a:ext>
             </a:extLst>
           </p:cNvPr>
@@ -8239,7 +8239,7 @@
           <p:cNvPr id="7" name="">
             <a:extLst xmlns:a="http://schemas.openxmlformats.org/drawingml/2006/main">
               <a:ext uri="{FF2B5EF4-FFF2-40B4-BE49-F238E27FC236}">
-                <a16:creationId xmlns:a16="http://schemas.microsoft.com/office/drawing/2014/main" id="{99D599F0-9554-4405-9780-3F1BA79C9E21}"/>
+                <a16:creationId xmlns:a16="http://schemas.microsoft.com/office/drawing/2014/main" id="{9DA0FBF9-FF07-4656-9FB8-4C97B3AB183C}"/>
               </a:ext>
             </a:extLst>
           </p:cNvPr>
@@ -8294,7 +8294,7 @@
     </p:spTree>
     <p:extLst>
       <p:ext uri="{BB962C8B-B14F-4D97-AF65-F5344CB8AC3E}">
-        <p14:creationId xmlns:p14="http://schemas.microsoft.com/office/powerpoint/2010/main" val="2033853544"/>
+        <p14:creationId xmlns:p14="http://schemas.microsoft.com/office/powerpoint/2010/main" val="997566463"/>
       </p:ext>
     </p:extLst>
   </p:cSld>
@@ -8325,7 +8325,7 @@
           <p:cNvPr id="10" name="">
             <a:extLst xmlns:a="http://schemas.openxmlformats.org/drawingml/2006/main">
               <a:ext uri="{FF2B5EF4-FFF2-40B4-BE49-F238E27FC236}">
-                <a16:creationId xmlns:a16="http://schemas.microsoft.com/office/drawing/2014/main" id="{971EAAA2-4496-4AA0-8FD3-A7F5E0CCA556}"/>
+                <a16:creationId xmlns:a16="http://schemas.microsoft.com/office/drawing/2014/main" id="{8D51AFAF-A627-44DF-81E1-2F49152741CF}"/>
               </a:ext>
             </a:extLst>
           </p:cNvPr>
@@ -8382,7 +8382,7 @@
           <p:cNvPr id="2" name="">
             <a:extLst xmlns:a="http://schemas.openxmlformats.org/drawingml/2006/main">
               <a:ext uri="{FF2B5EF4-FFF2-40B4-BE49-F238E27FC236}">
-                <a16:creationId xmlns:a16="http://schemas.microsoft.com/office/drawing/2014/main" id="{EDC3C074-6D4C-468D-970C-8F0C1BE2D048}"/>
+                <a16:creationId xmlns:a16="http://schemas.microsoft.com/office/drawing/2014/main" id="{4374503E-7B24-48CF-A7AC-0341ADBE6C6B}"/>
               </a:ext>
             </a:extLst>
           </p:cNvPr>
@@ -8412,7 +8412,7 @@
           <p:cNvPr id="3" name="">
             <a:extLst xmlns:a="http://schemas.openxmlformats.org/drawingml/2006/main">
               <a:ext uri="{FF2B5EF4-FFF2-40B4-BE49-F238E27FC236}">
-                <a16:creationId xmlns:a16="http://schemas.microsoft.com/office/drawing/2014/main" id="{573C5ADD-2876-4E72-B8A3-F89B29C13F9B}"/>
+                <a16:creationId xmlns:a16="http://schemas.microsoft.com/office/drawing/2014/main" id="{F4C9732E-6167-480F-9CCA-1BCEB98BBB2D}"/>
               </a:ext>
             </a:extLst>
           </p:cNvPr>
@@ -8476,7 +8476,7 @@
         </p:xfrm>
         <a:graphic xmlns:a="http://schemas.openxmlformats.org/drawingml/2006/main">
           <a:graphicData uri="http://schemas.openxmlformats.org/drawingml/2006/chart">
-            <c:chart xmlns:r="http://schemas.openxmlformats.org/officeDocument/2006/relationships" xmlns:c="http://schemas.openxmlformats.org/drawingml/2006/chart" r:id="R1f82885bfe8f4f5d"/>
+            <c:chart xmlns:r="http://schemas.openxmlformats.org/officeDocument/2006/relationships" xmlns:c="http://schemas.openxmlformats.org/drawingml/2006/chart" r:id="R69421a3fd5044181"/>
           </a:graphicData>
         </a:graphic>
       </p:graphicFrame>
@@ -8485,7 +8485,7 @@
           <p:cNvPr id="5" name="">
             <a:extLst xmlns:a="http://schemas.openxmlformats.org/drawingml/2006/main">
               <a:ext uri="{FF2B5EF4-FFF2-40B4-BE49-F238E27FC236}">
-                <a16:creationId xmlns:a16="http://schemas.microsoft.com/office/drawing/2014/main" id="{B9A3C4AD-DBA4-4FA2-9CA2-D694832407DF}"/>
+                <a16:creationId xmlns:a16="http://schemas.microsoft.com/office/drawing/2014/main" id="{128D7242-4D68-4018-8BD2-20AAF14FDB16}"/>
               </a:ext>
             </a:extLst>
           </p:cNvPr>
@@ -8532,7 +8532,7 @@
                 <a:ea typeface="Aptos"/>
                 <a:cs typeface="Aptos"/>
               </a:rPr>
-              <a:t>2 × increment</a:t>
+              <a:t>2 × resolution</a:t>
             </a:r>
           </a:p>
         </p:txBody>
@@ -8542,7 +8542,7 @@
           <p:cNvPr id="6" name="">
             <a:extLst xmlns:a="http://schemas.openxmlformats.org/drawingml/2006/main">
               <a:ext uri="{FF2B5EF4-FFF2-40B4-BE49-F238E27FC236}">
-                <a16:creationId xmlns:a16="http://schemas.microsoft.com/office/drawing/2014/main" id="{FF26DC73-46BD-4BBB-9A70-1479AE1F57E3}"/>
+                <a16:creationId xmlns:a16="http://schemas.microsoft.com/office/drawing/2014/main" id="{88917A92-6280-4FEE-B097-F5CBD6FD8AF4}"/>
               </a:ext>
             </a:extLst>
           </p:cNvPr>
@@ -8599,7 +8599,7 @@
           <p:cNvPr id="7" name="">
             <a:extLst xmlns:a="http://schemas.openxmlformats.org/drawingml/2006/main">
               <a:ext uri="{FF2B5EF4-FFF2-40B4-BE49-F238E27FC236}">
-                <a16:creationId xmlns:a16="http://schemas.microsoft.com/office/drawing/2014/main" id="{15916386-282F-4BF0-8565-F65398562C8D}"/>
+                <a16:creationId xmlns:a16="http://schemas.microsoft.com/office/drawing/2014/main" id="{478F97C4-B971-4297-90F0-C64FC2F1CFE6}"/>
               </a:ext>
             </a:extLst>
           </p:cNvPr>
@@ -8656,7 +8656,7 @@
           <p:cNvPr id="8" name="">
             <a:extLst xmlns:a="http://schemas.openxmlformats.org/drawingml/2006/main">
               <a:ext uri="{FF2B5EF4-FFF2-40B4-BE49-F238E27FC236}">
-                <a16:creationId xmlns:a16="http://schemas.microsoft.com/office/drawing/2014/main" id="{576ADC13-F0E5-4938-859E-763E85E6F2DA}"/>
+                <a16:creationId xmlns:a16="http://schemas.microsoft.com/office/drawing/2014/main" id="{6A4E1906-2371-437A-B0CD-335A209C1F4C}"/>
               </a:ext>
             </a:extLst>
           </p:cNvPr>
@@ -8713,7 +8713,7 @@
           <p:cNvPr id="9" name="">
             <a:extLst xmlns:a="http://schemas.openxmlformats.org/drawingml/2006/main">
               <a:ext uri="{FF2B5EF4-FFF2-40B4-BE49-F238E27FC236}">
-                <a16:creationId xmlns:a16="http://schemas.microsoft.com/office/drawing/2014/main" id="{5E7531CF-7BF6-4C02-8634-69011511406F}"/>
+                <a16:creationId xmlns:a16="http://schemas.microsoft.com/office/drawing/2014/main" id="{3793C274-08C2-4E56-AEFC-AF0073CA0D18}"/>
               </a:ext>
             </a:extLst>
           </p:cNvPr>
@@ -8768,7 +8768,7 @@
     </p:spTree>
     <p:extLst>
       <p:ext uri="{BB962C8B-B14F-4D97-AF65-F5344CB8AC3E}">
-        <p14:creationId xmlns:p14="http://schemas.microsoft.com/office/powerpoint/2010/main" val="1219087172"/>
+        <p14:creationId xmlns:p14="http://schemas.microsoft.com/office/powerpoint/2010/main" val="737459453"/>
       </p:ext>
     </p:extLst>
   </p:cSld>
@@ -8799,7 +8799,7 @@
           <p:cNvPr id="12" name="">
             <a:extLst xmlns:a="http://schemas.openxmlformats.org/drawingml/2006/main">
               <a:ext uri="{FF2B5EF4-FFF2-40B4-BE49-F238E27FC236}">
-                <a16:creationId xmlns:a16="http://schemas.microsoft.com/office/drawing/2014/main" id="{E0EF46F7-FF4B-43E5-9CBE-F04BA46DEA16}"/>
+                <a16:creationId xmlns:a16="http://schemas.microsoft.com/office/drawing/2014/main" id="{7E8302E4-C974-4FDE-92E8-7BE6E185ED53}"/>
               </a:ext>
             </a:extLst>
           </p:cNvPr>
@@ -8856,7 +8856,7 @@
           <p:cNvPr id="2" name="">
             <a:extLst xmlns:a="http://schemas.openxmlformats.org/drawingml/2006/main">
               <a:ext uri="{FF2B5EF4-FFF2-40B4-BE49-F238E27FC236}">
-                <a16:creationId xmlns:a16="http://schemas.microsoft.com/office/drawing/2014/main" id="{AB51A13E-0EBE-4CBA-B13A-C25D291346D2}"/>
+                <a16:creationId xmlns:a16="http://schemas.microsoft.com/office/drawing/2014/main" id="{53138B3A-E021-4A34-BC79-68BB36255E22}"/>
               </a:ext>
             </a:extLst>
           </p:cNvPr>
@@ -8886,7 +8886,7 @@
           <p:cNvPr id="3" name="">
             <a:extLst xmlns:a="http://schemas.openxmlformats.org/drawingml/2006/main">
               <a:ext uri="{FF2B5EF4-FFF2-40B4-BE49-F238E27FC236}">
-                <a16:creationId xmlns:a16="http://schemas.microsoft.com/office/drawing/2014/main" id="{F85782B3-EC01-4772-8740-1EE1D01420BB}"/>
+                <a16:creationId xmlns:a16="http://schemas.microsoft.com/office/drawing/2014/main" id="{69321519-151C-41D0-A2AA-FE0EC2B669DD}"/>
               </a:ext>
             </a:extLst>
           </p:cNvPr>
@@ -8947,7 +8947,7 @@
           <p:nvPr/>
         </p:nvPicPr>
         <p:blipFill>
-          <a:blip xmlns:r="http://schemas.openxmlformats.org/officeDocument/2006/relationships" xmlns:a="http://schemas.openxmlformats.org/drawingml/2006/main" r:embed="R3938e41215e9459f"/>
+          <a:blip xmlns:r="http://schemas.openxmlformats.org/officeDocument/2006/relationships" xmlns:a="http://schemas.openxmlformats.org/drawingml/2006/main" r:embed="R9bbabdbaeddd427e"/>
           <a:stretch xmlns:a="http://schemas.openxmlformats.org/drawingml/2006/main"/>
         </p:blipFill>
         <p:spPr>
@@ -8965,7 +8965,7 @@
           <p:cNvPr id="5" name="">
             <a:extLst xmlns:a="http://schemas.openxmlformats.org/drawingml/2006/main">
               <a:ext uri="{FF2B5EF4-FFF2-40B4-BE49-F238E27FC236}">
-                <a16:creationId xmlns:a16="http://schemas.microsoft.com/office/drawing/2014/main" id="{AE4B057E-6032-4FB5-A06D-2ECDF5530735}"/>
+                <a16:creationId xmlns:a16="http://schemas.microsoft.com/office/drawing/2014/main" id="{C58AA9D4-6737-4C1D-9C36-AE0D1C3225F3}"/>
               </a:ext>
             </a:extLst>
           </p:cNvPr>
@@ -9022,7 +9022,7 @@
           <p:cNvPr id="6" name="">
             <a:extLst xmlns:a="http://schemas.openxmlformats.org/drawingml/2006/main">
               <a:ext uri="{FF2B5EF4-FFF2-40B4-BE49-F238E27FC236}">
-                <a16:creationId xmlns:a16="http://schemas.microsoft.com/office/drawing/2014/main" id="{261788D2-4047-4FD1-A7CE-FC2775D0513D}"/>
+                <a16:creationId xmlns:a16="http://schemas.microsoft.com/office/drawing/2014/main" id="{C6092489-230F-408D-9097-8491E033082F}"/>
               </a:ext>
             </a:extLst>
           </p:cNvPr>
@@ -9079,7 +9079,7 @@
           <p:cNvPr id="7" name="">
             <a:extLst xmlns:a="http://schemas.openxmlformats.org/drawingml/2006/main">
               <a:ext uri="{FF2B5EF4-FFF2-40B4-BE49-F238E27FC236}">
-                <a16:creationId xmlns:a16="http://schemas.microsoft.com/office/drawing/2014/main" id="{67A087E0-8CAE-42A6-8FA3-893961D65ADB}"/>
+                <a16:creationId xmlns:a16="http://schemas.microsoft.com/office/drawing/2014/main" id="{11EF9AAC-3534-47F9-BB5C-F109C5970438}"/>
               </a:ext>
             </a:extLst>
           </p:cNvPr>
@@ -9136,7 +9136,7 @@
           <p:cNvPr id="8" name="">
             <a:extLst xmlns:a="http://schemas.openxmlformats.org/drawingml/2006/main">
               <a:ext uri="{FF2B5EF4-FFF2-40B4-BE49-F238E27FC236}">
-                <a16:creationId xmlns:a16="http://schemas.microsoft.com/office/drawing/2014/main" id="{FE79E8FE-0D71-453B-9616-E80DDB89BE3E}"/>
+                <a16:creationId xmlns:a16="http://schemas.microsoft.com/office/drawing/2014/main" id="{D38A7B1C-AEE6-444F-8C68-4291737594C8}"/>
               </a:ext>
             </a:extLst>
           </p:cNvPr>
@@ -9193,7 +9193,7 @@
           <p:cNvPr id="9" name="">
             <a:extLst xmlns:a="http://schemas.openxmlformats.org/drawingml/2006/main">
               <a:ext uri="{FF2B5EF4-FFF2-40B4-BE49-F238E27FC236}">
-                <a16:creationId xmlns:a16="http://schemas.microsoft.com/office/drawing/2014/main" id="{7451898A-8180-4617-AF7E-45A1806CDBCE}"/>
+                <a16:creationId xmlns:a16="http://schemas.microsoft.com/office/drawing/2014/main" id="{18C69E53-DFCA-4A14-8132-B99775E6AB2E}"/>
               </a:ext>
             </a:extLst>
           </p:cNvPr>
@@ -9250,7 +9250,7 @@
           <p:cNvPr id="10" name="">
             <a:extLst xmlns:a="http://schemas.openxmlformats.org/drawingml/2006/main">
               <a:ext uri="{FF2B5EF4-FFF2-40B4-BE49-F238E27FC236}">
-                <a16:creationId xmlns:a16="http://schemas.microsoft.com/office/drawing/2014/main" id="{D1C8AAAF-295C-401D-939C-86DB92F3424D}"/>
+                <a16:creationId xmlns:a16="http://schemas.microsoft.com/office/drawing/2014/main" id="{51121ABA-492B-482B-9A0C-514F0D5FE271}"/>
               </a:ext>
             </a:extLst>
           </p:cNvPr>
@@ -9307,7 +9307,7 @@
           <p:cNvPr id="11" name="">
             <a:extLst xmlns:a="http://schemas.openxmlformats.org/drawingml/2006/main">
               <a:ext uri="{FF2B5EF4-FFF2-40B4-BE49-F238E27FC236}">
-                <a16:creationId xmlns:a16="http://schemas.microsoft.com/office/drawing/2014/main" id="{9548C602-95A7-4A98-949B-5534E98DC081}"/>
+                <a16:creationId xmlns:a16="http://schemas.microsoft.com/office/drawing/2014/main" id="{5DAEDC11-2129-478E-9ECC-F8DDB3B78D78}"/>
               </a:ext>
             </a:extLst>
           </p:cNvPr>
@@ -9362,7 +9362,7 @@
     </p:spTree>
     <p:extLst>
       <p:ext uri="{BB962C8B-B14F-4D97-AF65-F5344CB8AC3E}">
-        <p14:creationId xmlns:p14="http://schemas.microsoft.com/office/powerpoint/2010/main" val="423678801"/>
+        <p14:creationId xmlns:p14="http://schemas.microsoft.com/office/powerpoint/2010/main" val="331645958"/>
       </p:ext>
     </p:extLst>
   </p:cSld>
@@ -9393,7 +9393,7 @@
           <p:cNvPr id="11" name="">
             <a:extLst xmlns:a="http://schemas.openxmlformats.org/drawingml/2006/main">
               <a:ext uri="{FF2B5EF4-FFF2-40B4-BE49-F238E27FC236}">
-                <a16:creationId xmlns:a16="http://schemas.microsoft.com/office/drawing/2014/main" id="{356579CF-8FCD-4439-8941-C06E6BE1F182}"/>
+                <a16:creationId xmlns:a16="http://schemas.microsoft.com/office/drawing/2014/main" id="{4A3D1CC3-87E4-4FE1-8256-25C55991FD0C}"/>
               </a:ext>
             </a:extLst>
           </p:cNvPr>
@@ -9450,7 +9450,7 @@
           <p:cNvPr id="2" name="">
             <a:extLst xmlns:a="http://schemas.openxmlformats.org/drawingml/2006/main">
               <a:ext uri="{FF2B5EF4-FFF2-40B4-BE49-F238E27FC236}">
-                <a16:creationId xmlns:a16="http://schemas.microsoft.com/office/drawing/2014/main" id="{3E593E73-FC61-4E11-AFD5-E8D687454FE7}"/>
+                <a16:creationId xmlns:a16="http://schemas.microsoft.com/office/drawing/2014/main" id="{477702A0-496E-42B2-BC2D-6929A9D81CCF}"/>
               </a:ext>
             </a:extLst>
           </p:cNvPr>
@@ -9480,7 +9480,7 @@
           <p:cNvPr id="3" name="">
             <a:extLst xmlns:a="http://schemas.openxmlformats.org/drawingml/2006/main">
               <a:ext uri="{FF2B5EF4-FFF2-40B4-BE49-F238E27FC236}">
-                <a16:creationId xmlns:a16="http://schemas.microsoft.com/office/drawing/2014/main" id="{0DB8F814-04B9-47FA-BF50-7654676047FD}"/>
+                <a16:creationId xmlns:a16="http://schemas.microsoft.com/office/drawing/2014/main" id="{A23EECB6-BDAE-4488-A45C-8A7D6FDA75F5}"/>
               </a:ext>
             </a:extLst>
           </p:cNvPr>
@@ -9541,7 +9541,7 @@
           <p:nvPr/>
         </p:nvPicPr>
         <p:blipFill>
-          <a:blip xmlns:r="http://schemas.openxmlformats.org/officeDocument/2006/relationships" xmlns:a="http://schemas.openxmlformats.org/drawingml/2006/main" r:embed="R5756043aa1e94ad5"/>
+          <a:blip xmlns:r="http://schemas.openxmlformats.org/officeDocument/2006/relationships" xmlns:a="http://schemas.openxmlformats.org/drawingml/2006/main" r:embed="R710358d5fe754b96"/>
           <a:stretch xmlns:a="http://schemas.openxmlformats.org/drawingml/2006/main"/>
         </p:blipFill>
         <p:spPr>
@@ -9563,13 +9563,13 @@
           <p:nvPr/>
         </p:nvPicPr>
         <p:blipFill>
-          <a:blip xmlns:r="http://schemas.openxmlformats.org/officeDocument/2006/relationships" xmlns:a="http://schemas.openxmlformats.org/drawingml/2006/main" r:embed="Rf21637a3abe64e46"/>
+          <a:blip xmlns:r="http://schemas.openxmlformats.org/officeDocument/2006/relationships" xmlns:a="http://schemas.openxmlformats.org/drawingml/2006/main" r:embed="R4f3d8f29db994fa6"/>
           <a:stretch xmlns:a="http://schemas.openxmlformats.org/drawingml/2006/main"/>
         </p:blipFill>
         <p:spPr>
           <a:xfrm xmlns:a="http://schemas.openxmlformats.org/drawingml/2006/main">
-            <a:off x="4333875" y="1791644"/>
-            <a:ext cx="3286125" cy="3084213"/>
+            <a:off x="4333875" y="1737632"/>
+            <a:ext cx="3286125" cy="3192236"/>
           </a:xfrm>
           <a:prstGeom xmlns:a="http://schemas.openxmlformats.org/drawingml/2006/main" prst="rect">
             <a:avLst/>
@@ -9585,7 +9585,7 @@
           <p:nvPr/>
         </p:nvPicPr>
         <p:blipFill>
-          <a:blip xmlns:r="http://schemas.openxmlformats.org/officeDocument/2006/relationships" xmlns:a="http://schemas.openxmlformats.org/drawingml/2006/main" r:embed="R9bd4c31f42924c1d"/>
+          <a:blip xmlns:r="http://schemas.openxmlformats.org/officeDocument/2006/relationships" xmlns:a="http://schemas.openxmlformats.org/drawingml/2006/main" r:embed="Rf9152c1ed09e4051"/>
           <a:stretch xmlns:a="http://schemas.openxmlformats.org/drawingml/2006/main"/>
         </p:blipFill>
         <p:spPr>
@@ -9603,7 +9603,7 @@
           <p:cNvPr id="7" name="">
             <a:extLst xmlns:a="http://schemas.openxmlformats.org/drawingml/2006/main">
               <a:ext uri="{FF2B5EF4-FFF2-40B4-BE49-F238E27FC236}">
-                <a16:creationId xmlns:a16="http://schemas.microsoft.com/office/drawing/2014/main" id="{C885E577-8501-4A1A-9181-AB1919102234}"/>
+                <a16:creationId xmlns:a16="http://schemas.microsoft.com/office/drawing/2014/main" id="{731C159D-2C19-4358-AF19-D122A866C638}"/>
               </a:ext>
             </a:extLst>
           </p:cNvPr>
@@ -9660,7 +9660,7 @@
           <p:cNvPr id="8" name="">
             <a:extLst xmlns:a="http://schemas.openxmlformats.org/drawingml/2006/main">
               <a:ext uri="{FF2B5EF4-FFF2-40B4-BE49-F238E27FC236}">
-                <a16:creationId xmlns:a16="http://schemas.microsoft.com/office/drawing/2014/main" id="{F8263AED-1A3B-49E3-86A0-00C1CB8DEC5A}"/>
+                <a16:creationId xmlns:a16="http://schemas.microsoft.com/office/drawing/2014/main" id="{FE2DB445-F3BE-4A05-A55A-F2FB5975821E}"/>
               </a:ext>
             </a:extLst>
           </p:cNvPr>
@@ -9717,7 +9717,7 @@
           <p:cNvPr id="9" name="">
             <a:extLst xmlns:a="http://schemas.openxmlformats.org/drawingml/2006/main">
               <a:ext uri="{FF2B5EF4-FFF2-40B4-BE49-F238E27FC236}">
-                <a16:creationId xmlns:a16="http://schemas.microsoft.com/office/drawing/2014/main" id="{290DB695-BDDC-4453-81ED-B5D7304DFCAA}"/>
+                <a16:creationId xmlns:a16="http://schemas.microsoft.com/office/drawing/2014/main" id="{C68F2A54-0349-46AB-9193-785C831317BB}"/>
               </a:ext>
             </a:extLst>
           </p:cNvPr>
@@ -9774,7 +9774,7 @@
           <p:cNvPr id="10" name="">
             <a:extLst xmlns:a="http://schemas.openxmlformats.org/drawingml/2006/main">
               <a:ext uri="{FF2B5EF4-FFF2-40B4-BE49-F238E27FC236}">
-                <a16:creationId xmlns:a16="http://schemas.microsoft.com/office/drawing/2014/main" id="{06CC8EEB-0BFC-4071-A50B-54EDAF696270}"/>
+                <a16:creationId xmlns:a16="http://schemas.microsoft.com/office/drawing/2014/main" id="{C3944719-E6AD-4ADF-B2A6-4DFF00E8F8C3}"/>
               </a:ext>
             </a:extLst>
           </p:cNvPr>
@@ -9829,7 +9829,7 @@
     </p:spTree>
     <p:extLst>
       <p:ext uri="{BB962C8B-B14F-4D97-AF65-F5344CB8AC3E}">
-        <p14:creationId xmlns:p14="http://schemas.microsoft.com/office/powerpoint/2010/main" val="98658728"/>
+        <p14:creationId xmlns:p14="http://schemas.microsoft.com/office/powerpoint/2010/main" val="1882892943"/>
       </p:ext>
     </p:extLst>
   </p:cSld>

</xml_diff>